<commit_message>
Update midterm presentation with speaker notes for slides 11 through 17 and Q&A prep.
</commit_message>
<xml_diff>
--- a/Olympic_Economics_Midterm Presentation.pptx
+++ b/Olympic_Economics_Midterm Presentation.pptx
@@ -137,6 +137,1255 @@
     </p:ext>
   </p:extLst>
 </p:presentation>
+</file>
+
+<file path=ppt/notesMasters/notesMaster1.xml><?xml version="1.0" encoding="utf-8"?>
+<p:notesMaster xmlns:a="http://schemas.openxmlformats.org/drawingml/2006/main" xmlns:p="http://schemas.openxmlformats.org/presentationml/2006/main" xmlns:r="http://schemas.openxmlformats.org/officeDocument/2006/relationships">
+  <p:cSld>
+    <p:bg>
+      <p:bgRef idx="1001">
+        <a:schemeClr val="bg1"/>
+      </p:bgRef>
+    </p:bg>
+    <p:spTree>
+      <p:nvGrpSpPr>
+        <p:cNvPr id="1" name=""/>
+        <p:cNvGrpSpPr/>
+        <p:nvPr/>
+      </p:nvGrpSpPr>
+      <p:grpSpPr>
+        <a:xfrm>
+          <a:off x="0" y="0"/>
+          <a:ext cx="0" cy="0"/>
+          <a:chOff x="0" y="0"/>
+          <a:chExt cx="0" cy="0"/>
+        </a:xfrm>
+      </p:grpSpPr>
+      <p:sp>
+        <p:nvSpPr>
+          <p:cNvPr id="2" name="Header Placeholder 1"/>
+          <p:cNvSpPr>
+            <a:spLocks noGrp="1"/>
+          </p:cNvSpPr>
+          <p:nvPr>
+            <p:ph type="hdr" sz="quarter"/>
+          </p:nvPr>
+        </p:nvSpPr>
+        <p:spPr>
+          <a:xfrm>
+            <a:off x="0" y="0"/>
+            <a:ext cx="2971800" cy="457200"/>
+          </a:xfrm>
+          <a:prstGeom prst="rect">
+            <a:avLst/>
+          </a:prstGeom>
+        </p:spPr>
+        <p:txBody>
+          <a:bodyPr vert="horz" lIns="91440" tIns="45720" rIns="91440" bIns="45720" rtlCol="0"/>
+          <a:lstStyle>
+            <a:lvl1pPr algn="l">
+              <a:defRPr sz="1200"/>
+            </a:lvl1pPr>
+          </a:lstStyle>
+          <a:p>
+            <a:endParaRPr lang="en-US"/>
+          </a:p>
+        </p:txBody>
+      </p:sp>
+      <p:sp>
+        <p:nvSpPr>
+          <p:cNvPr id="3" name="Date Placeholder 2"/>
+          <p:cNvSpPr>
+            <a:spLocks noGrp="1"/>
+          </p:cNvSpPr>
+          <p:nvPr>
+            <p:ph type="dt" idx="1"/>
+          </p:nvPr>
+        </p:nvSpPr>
+        <p:spPr>
+          <a:xfrm>
+            <a:off x="3884613" y="0"/>
+            <a:ext cx="2971800" cy="457200"/>
+          </a:xfrm>
+          <a:prstGeom prst="rect">
+            <a:avLst/>
+          </a:prstGeom>
+        </p:spPr>
+        <p:txBody>
+          <a:bodyPr vert="horz" lIns="91440" tIns="45720" rIns="91440" bIns="45720" rtlCol="0"/>
+          <a:lstStyle>
+            <a:lvl1pPr algn="r">
+              <a:defRPr sz="1200"/>
+            </a:lvl1pPr>
+          </a:lstStyle>
+          <a:p>
+            <a:fld id="{0F89C1C7-3DCD-1040-A9CF-14679D8B5DDD}" type="datetimeFigureOut">
+              <a:rPr lang="en-US" smtClean="0"/>
+              <a:t>10/17/16</a:t>
+            </a:fld>
+            <a:endParaRPr lang="en-US"/>
+          </a:p>
+        </p:txBody>
+      </p:sp>
+      <p:sp>
+        <p:nvSpPr>
+          <p:cNvPr id="4" name="Slide Image Placeholder 3"/>
+          <p:cNvSpPr>
+            <a:spLocks noGrp="1" noRot="1" noChangeAspect="1"/>
+          </p:cNvSpPr>
+          <p:nvPr>
+            <p:ph type="sldImg" idx="2"/>
+          </p:nvPr>
+        </p:nvSpPr>
+        <p:spPr>
+          <a:xfrm>
+            <a:off x="1143000" y="685800"/>
+            <a:ext cx="4572000" cy="3429000"/>
+          </a:xfrm>
+          <a:prstGeom prst="rect">
+            <a:avLst/>
+          </a:prstGeom>
+          <a:noFill/>
+          <a:ln w="12700">
+            <a:solidFill>
+              <a:prstClr val="black"/>
+            </a:solidFill>
+          </a:ln>
+        </p:spPr>
+        <p:txBody>
+          <a:bodyPr vert="horz" lIns="91440" tIns="45720" rIns="91440" bIns="45720" rtlCol="0" anchor="ctr"/>
+          <a:lstStyle/>
+          <a:p>
+            <a:endParaRPr lang="en-US"/>
+          </a:p>
+        </p:txBody>
+      </p:sp>
+      <p:sp>
+        <p:nvSpPr>
+          <p:cNvPr id="5" name="Notes Placeholder 4"/>
+          <p:cNvSpPr>
+            <a:spLocks noGrp="1"/>
+          </p:cNvSpPr>
+          <p:nvPr>
+            <p:ph type="body" sz="quarter" idx="3"/>
+          </p:nvPr>
+        </p:nvSpPr>
+        <p:spPr>
+          <a:xfrm>
+            <a:off x="685800" y="4343400"/>
+            <a:ext cx="5486400" cy="4114800"/>
+          </a:xfrm>
+          <a:prstGeom prst="rect">
+            <a:avLst/>
+          </a:prstGeom>
+        </p:spPr>
+        <p:txBody>
+          <a:bodyPr vert="horz" lIns="91440" tIns="45720" rIns="91440" bIns="45720" rtlCol="0"/>
+          <a:lstStyle/>
+          <a:p>
+            <a:pPr lvl="0"/>
+            <a:r>
+              <a:rPr lang="en-US" smtClean="0"/>
+              <a:t>Click to edit Master text styles</a:t>
+            </a:r>
+          </a:p>
+          <a:p>
+            <a:pPr lvl="1"/>
+            <a:r>
+              <a:rPr lang="en-US" smtClean="0"/>
+              <a:t>Second level</a:t>
+            </a:r>
+          </a:p>
+          <a:p>
+            <a:pPr lvl="2"/>
+            <a:r>
+              <a:rPr lang="en-US" smtClean="0"/>
+              <a:t>Third level</a:t>
+            </a:r>
+          </a:p>
+          <a:p>
+            <a:pPr lvl="3"/>
+            <a:r>
+              <a:rPr lang="en-US" smtClean="0"/>
+              <a:t>Fourth level</a:t>
+            </a:r>
+          </a:p>
+          <a:p>
+            <a:pPr lvl="4"/>
+            <a:r>
+              <a:rPr lang="en-US" smtClean="0"/>
+              <a:t>Fifth level</a:t>
+            </a:r>
+            <a:endParaRPr lang="en-US"/>
+          </a:p>
+        </p:txBody>
+      </p:sp>
+      <p:sp>
+        <p:nvSpPr>
+          <p:cNvPr id="6" name="Footer Placeholder 5"/>
+          <p:cNvSpPr>
+            <a:spLocks noGrp="1"/>
+          </p:cNvSpPr>
+          <p:nvPr>
+            <p:ph type="ftr" sz="quarter" idx="4"/>
+          </p:nvPr>
+        </p:nvSpPr>
+        <p:spPr>
+          <a:xfrm>
+            <a:off x="0" y="8685213"/>
+            <a:ext cx="2971800" cy="457200"/>
+          </a:xfrm>
+          <a:prstGeom prst="rect">
+            <a:avLst/>
+          </a:prstGeom>
+        </p:spPr>
+        <p:txBody>
+          <a:bodyPr vert="horz" lIns="91440" tIns="45720" rIns="91440" bIns="45720" rtlCol="0" anchor="b"/>
+          <a:lstStyle>
+            <a:lvl1pPr algn="l">
+              <a:defRPr sz="1200"/>
+            </a:lvl1pPr>
+          </a:lstStyle>
+          <a:p>
+            <a:endParaRPr lang="en-US"/>
+          </a:p>
+        </p:txBody>
+      </p:sp>
+      <p:sp>
+        <p:nvSpPr>
+          <p:cNvPr id="7" name="Slide Number Placeholder 6"/>
+          <p:cNvSpPr>
+            <a:spLocks noGrp="1"/>
+          </p:cNvSpPr>
+          <p:nvPr>
+            <p:ph type="sldNum" sz="quarter" idx="5"/>
+          </p:nvPr>
+        </p:nvSpPr>
+        <p:spPr>
+          <a:xfrm>
+            <a:off x="3884613" y="8685213"/>
+            <a:ext cx="2971800" cy="457200"/>
+          </a:xfrm>
+          <a:prstGeom prst="rect">
+            <a:avLst/>
+          </a:prstGeom>
+        </p:spPr>
+        <p:txBody>
+          <a:bodyPr vert="horz" lIns="91440" tIns="45720" rIns="91440" bIns="45720" rtlCol="0" anchor="b"/>
+          <a:lstStyle>
+            <a:lvl1pPr algn="r">
+              <a:defRPr sz="1200"/>
+            </a:lvl1pPr>
+          </a:lstStyle>
+          <a:p>
+            <a:fld id="{BB5E49A5-4136-284D-997B-48E1D791AD67}" type="slidenum">
+              <a:rPr lang="en-US" smtClean="0"/>
+              <a:t>‹#›</a:t>
+            </a:fld>
+            <a:endParaRPr lang="en-US"/>
+          </a:p>
+        </p:txBody>
+      </p:sp>
+    </p:spTree>
+    <p:extLst>
+      <p:ext uri="{BB962C8B-B14F-4D97-AF65-F5344CB8AC3E}">
+        <p14:creationId xmlns:p14="http://schemas.microsoft.com/office/powerpoint/2010/main" val="2623252185"/>
+      </p:ext>
+    </p:extLst>
+  </p:cSld>
+  <p:clrMap bg1="lt1" tx1="dk1" bg2="lt2" tx2="dk2" accent1="accent1" accent2="accent2" accent3="accent3" accent4="accent4" accent5="accent5" accent6="accent6" hlink="hlink" folHlink="folHlink"/>
+  <p:notesStyle>
+    <a:lvl1pPr marL="0" algn="l" defTabSz="457200" rtl="0" eaLnBrk="1" latinLnBrk="0" hangingPunct="1">
+      <a:defRPr sz="1200" kern="1200">
+        <a:solidFill>
+          <a:schemeClr val="tx1"/>
+        </a:solidFill>
+        <a:latin typeface="+mn-lt"/>
+        <a:ea typeface="+mn-ea"/>
+        <a:cs typeface="+mn-cs"/>
+      </a:defRPr>
+    </a:lvl1pPr>
+    <a:lvl2pPr marL="457200" algn="l" defTabSz="457200" rtl="0" eaLnBrk="1" latinLnBrk="0" hangingPunct="1">
+      <a:defRPr sz="1200" kern="1200">
+        <a:solidFill>
+          <a:schemeClr val="tx1"/>
+        </a:solidFill>
+        <a:latin typeface="+mn-lt"/>
+        <a:ea typeface="+mn-ea"/>
+        <a:cs typeface="+mn-cs"/>
+      </a:defRPr>
+    </a:lvl2pPr>
+    <a:lvl3pPr marL="914400" algn="l" defTabSz="457200" rtl="0" eaLnBrk="1" latinLnBrk="0" hangingPunct="1">
+      <a:defRPr sz="1200" kern="1200">
+        <a:solidFill>
+          <a:schemeClr val="tx1"/>
+        </a:solidFill>
+        <a:latin typeface="+mn-lt"/>
+        <a:ea typeface="+mn-ea"/>
+        <a:cs typeface="+mn-cs"/>
+      </a:defRPr>
+    </a:lvl3pPr>
+    <a:lvl4pPr marL="1371600" algn="l" defTabSz="457200" rtl="0" eaLnBrk="1" latinLnBrk="0" hangingPunct="1">
+      <a:defRPr sz="1200" kern="1200">
+        <a:solidFill>
+          <a:schemeClr val="tx1"/>
+        </a:solidFill>
+        <a:latin typeface="+mn-lt"/>
+        <a:ea typeface="+mn-ea"/>
+        <a:cs typeface="+mn-cs"/>
+      </a:defRPr>
+    </a:lvl4pPr>
+    <a:lvl5pPr marL="1828800" algn="l" defTabSz="457200" rtl="0" eaLnBrk="1" latinLnBrk="0" hangingPunct="1">
+      <a:defRPr sz="1200" kern="1200">
+        <a:solidFill>
+          <a:schemeClr val="tx1"/>
+        </a:solidFill>
+        <a:latin typeface="+mn-lt"/>
+        <a:ea typeface="+mn-ea"/>
+        <a:cs typeface="+mn-cs"/>
+      </a:defRPr>
+    </a:lvl5pPr>
+    <a:lvl6pPr marL="2286000" algn="l" defTabSz="457200" rtl="0" eaLnBrk="1" latinLnBrk="0" hangingPunct="1">
+      <a:defRPr sz="1200" kern="1200">
+        <a:solidFill>
+          <a:schemeClr val="tx1"/>
+        </a:solidFill>
+        <a:latin typeface="+mn-lt"/>
+        <a:ea typeface="+mn-ea"/>
+        <a:cs typeface="+mn-cs"/>
+      </a:defRPr>
+    </a:lvl6pPr>
+    <a:lvl7pPr marL="2743200" algn="l" defTabSz="457200" rtl="0" eaLnBrk="1" latinLnBrk="0" hangingPunct="1">
+      <a:defRPr sz="1200" kern="1200">
+        <a:solidFill>
+          <a:schemeClr val="tx1"/>
+        </a:solidFill>
+        <a:latin typeface="+mn-lt"/>
+        <a:ea typeface="+mn-ea"/>
+        <a:cs typeface="+mn-cs"/>
+      </a:defRPr>
+    </a:lvl7pPr>
+    <a:lvl8pPr marL="3200400" algn="l" defTabSz="457200" rtl="0" eaLnBrk="1" latinLnBrk="0" hangingPunct="1">
+      <a:defRPr sz="1200" kern="1200">
+        <a:solidFill>
+          <a:schemeClr val="tx1"/>
+        </a:solidFill>
+        <a:latin typeface="+mn-lt"/>
+        <a:ea typeface="+mn-ea"/>
+        <a:cs typeface="+mn-cs"/>
+      </a:defRPr>
+    </a:lvl8pPr>
+    <a:lvl9pPr marL="3657600" algn="l" defTabSz="457200" rtl="0" eaLnBrk="1" latinLnBrk="0" hangingPunct="1">
+      <a:defRPr sz="1200" kern="1200">
+        <a:solidFill>
+          <a:schemeClr val="tx1"/>
+        </a:solidFill>
+        <a:latin typeface="+mn-lt"/>
+        <a:ea typeface="+mn-ea"/>
+        <a:cs typeface="+mn-cs"/>
+      </a:defRPr>
+    </a:lvl9pPr>
+  </p:notesStyle>
+</p:notesMaster>
+</file>
+
+<file path=ppt/notesSlides/notesSlide1.xml><?xml version="1.0" encoding="utf-8"?>
+<p:notes xmlns:a="http://schemas.openxmlformats.org/drawingml/2006/main" xmlns:p="http://schemas.openxmlformats.org/presentationml/2006/main" xmlns:r="http://schemas.openxmlformats.org/officeDocument/2006/relationships">
+  <p:cSld>
+    <p:spTree>
+      <p:nvGrpSpPr>
+        <p:cNvPr id="1" name=""/>
+        <p:cNvGrpSpPr/>
+        <p:nvPr/>
+      </p:nvGrpSpPr>
+      <p:grpSpPr>
+        <a:xfrm>
+          <a:off x="0" y="0"/>
+          <a:ext cx="0" cy="0"/>
+          <a:chOff x="0" y="0"/>
+          <a:chExt cx="0" cy="0"/>
+        </a:xfrm>
+      </p:grpSpPr>
+      <p:sp>
+        <p:nvSpPr>
+          <p:cNvPr id="2" name="Slide Image Placeholder 1"/>
+          <p:cNvSpPr>
+            <a:spLocks noGrp="1"/>
+          </p:cNvSpPr>
+          <p:nvPr>
+            <p:ph type="sldImg" idx="2"/>
+          </p:nvPr>
+        </p:nvSpPr>
+        <p:spPr/>
+      </p:sp>
+      <p:sp>
+        <p:nvSpPr>
+          <p:cNvPr id="3" name="Notes Placeholder 2"/>
+          <p:cNvSpPr>
+            <a:spLocks noGrp="1"/>
+          </p:cNvSpPr>
+          <p:nvPr>
+            <p:ph type="body" idx="3" sz="quarter"/>
+          </p:nvPr>
+        </p:nvSpPr>
+        <p:spPr/>
+        <p:txBody>
+          <a:bodyPr/>
+          <a:lstStyle/>
+          <a:p>
+            <a:r>
+              <a:t>SLIDE 11 — Null baseline (about 1.5 minutes)</a:t>
+            </a:r>
+          </a:p>
+          <a:p/>
+          <a:p>
+            <a:r>
+              <a:t>Opening: This section is where we show whether our models are actually learning anything, or just repeating an obvious guess.</a:t>
+            </a:r>
+          </a:p>
+          <a:p/>
+          <a:p>
+            <a:r>
+              <a:t>Say: Our null baseline for regression is deliberately dumb but fair. For every country in the 2016 test set, we predict the same number: the average total medals from the training countries. We ignore population, GDP, health spending, team size, and every other feature. That is the floor any real model has to beat.</a:t>
+            </a:r>
+          </a:p>
+          <a:p/>
+          <a:p>
+            <a:r>
+              <a:t>Say: We report MAE and R-squared on the same 25 percent holdout of countries, with the same random split every time, so comparisons are apples to apples. MAE is in medals: how far off we are on average. R-squared tells us whether we explain variation beyond a flat guess.</a:t>
+            </a:r>
+          </a:p>
+          <a:p/>
+          <a:p>
+            <a:r>
+              <a:t>Walk the numbers on the slide: Null baseline MAE about 6.8 medals and R-squared essentially zero, about negative 0.004. That means predicting the mean is almost useless for spread across countries. The grouped null variant is similar in R-squared; MAE can differ slightly depending on which countries sit in the test fold.</a:t>
+            </a:r>
+          </a:p>
+          <a:p/>
+          <a:p>
+            <a:r>
+              <a:t>Transition: If economic indicators matter, our Ridge and tree models should beat this baseline clearly on MAE and R-squared.</a:t>
+            </a:r>
+          </a:p>
+        </p:txBody>
+      </p:sp>
+      <p:sp>
+        <p:nvSpPr>
+          <p:cNvPr id="4" name="Slide Number Placeholder 3"/>
+          <p:cNvSpPr>
+            <a:spLocks noGrp="1"/>
+          </p:cNvSpPr>
+          <p:nvPr>
+            <p:ph type="sldNum" idx="5" sz="quarter"/>
+          </p:nvPr>
+        </p:nvSpPr>
+        <p:spPr/>
+      </p:sp>
+    </p:spTree>
+  </p:cSld>
+  <p:clrMapOvr>
+    <a:masterClrMapping/>
+  </p:clrMapOvr>
+</p:notes>
+</file>
+
+<file path=ppt/notesSlides/notesSlide2.xml><?xml version="1.0" encoding="utf-8"?>
+<p:notes xmlns:a="http://schemas.openxmlformats.org/drawingml/2006/main" xmlns:p="http://schemas.openxmlformats.org/presentationml/2006/main" xmlns:r="http://schemas.openxmlformats.org/officeDocument/2006/relationships">
+  <p:cSld>
+    <p:spTree>
+      <p:nvGrpSpPr>
+        <p:cNvPr id="1" name=""/>
+        <p:cNvGrpSpPr/>
+        <p:nvPr/>
+      </p:nvGrpSpPr>
+      <p:grpSpPr>
+        <a:xfrm>
+          <a:off x="0" y="0"/>
+          <a:ext cx="0" cy="0"/>
+          <a:chOff x="0" y="0"/>
+          <a:chExt cx="0" cy="0"/>
+        </a:xfrm>
+      </p:grpSpPr>
+      <p:sp>
+        <p:nvSpPr>
+          <p:cNvPr id="2" name="Slide Image Placeholder 1"/>
+          <p:cNvSpPr>
+            <a:spLocks noGrp="1"/>
+          </p:cNvSpPr>
+          <p:nvPr>
+            <p:ph type="sldImg" idx="2"/>
+          </p:nvPr>
+        </p:nvSpPr>
+        <p:spPr/>
+      </p:sp>
+      <p:sp>
+        <p:nvSpPr>
+          <p:cNvPr id="3" name="Notes Placeholder 2"/>
+          <p:cNvSpPr>
+            <a:spLocks noGrp="1"/>
+          </p:cNvSpPr>
+          <p:nvPr>
+            <p:ph type="body" idx="3" sz="quarter"/>
+          </p:nvPr>
+        </p:nvSpPr>
+        <p:spPr/>
+        <p:txBody>
+          <a:bodyPr/>
+          <a:lstStyle/>
+          <a:p>
+            <a:r>
+              <a:t>SLIDE 12 — Ridge beats the null (about 1.5 minutes)</a:t>
+            </a:r>
+          </a:p>
+          <a:p/>
+          <a:p>
+            <a:r>
+              <a:t>Opening: Here we answer the first stakeholder question: do economic predictors add value beyond a constant guess?</a:t>
+            </a:r>
+          </a:p>
+          <a:p/>
+          <a:p>
+            <a:r>
+              <a:t>Say: The left comparison is MAE for the plain null versus Ridge with all well-covered economic factors, about 33 indicators with at least 80 percent coverage among our 2016 modeling countries. Error drops from about 6.781 to about 3.708 medals on average. That is roughly a 45 percent reduction in MAE, which is a large practical improvement for planning scenarios.</a:t>
+            </a:r>
+          </a:p>
+          <a:p/>
+          <a:p>
+            <a:r>
+              <a:t>Say: We also trained Ridge with country groups and without direct GDP and population columns in the feature matrix. That grouped Ridge lands around 5.873 MAE. It still beats the simple null on this slide in some setups, but it is much worse than the all-factor Ridge. The story is that size and wealth still carry a lot of signal, even when we try to summarize countries with groups.</a:t>
+            </a:r>
+          </a:p>
+          <a:p/>
+          <a:p>
+            <a:r>
+              <a:t>Point at the grouped null baseline number if shown (about 8.538): remind the audience that baselines must match the same sample; we always compare models trained and tested on the same countries.</a:t>
+            </a:r>
+          </a:p>
+          <a:p/>
+          <a:p>
+            <a:r>
+              <a:t>Transition: Slide 13 puts every regression model side by side on R-squared and MAE.</a:t>
+            </a:r>
+          </a:p>
+        </p:txBody>
+      </p:sp>
+      <p:sp>
+        <p:nvSpPr>
+          <p:cNvPr id="4" name="Slide Number Placeholder 3"/>
+          <p:cNvSpPr>
+            <a:spLocks noGrp="1"/>
+          </p:cNvSpPr>
+          <p:nvPr>
+            <p:ph type="sldNum" idx="5" sz="quarter"/>
+          </p:nvPr>
+        </p:nvSpPr>
+        <p:spPr/>
+      </p:sp>
+    </p:spTree>
+  </p:cSld>
+  <p:clrMapOvr>
+    <a:masterClrMapping/>
+  </p:clrMapOvr>
+</p:notes>
+</file>
+
+<file path=ppt/notesSlides/notesSlide3.xml><?xml version="1.0" encoding="utf-8"?>
+<p:notes xmlns:a="http://schemas.openxmlformats.org/drawingml/2006/main" xmlns:p="http://schemas.openxmlformats.org/presentationml/2006/main" xmlns:r="http://schemas.openxmlformats.org/officeDocument/2006/relationships">
+  <p:cSld>
+    <p:spTree>
+      <p:nvGrpSpPr>
+        <p:cNvPr id="1" name=""/>
+        <p:cNvGrpSpPr/>
+        <p:nvPr/>
+      </p:nvGrpSpPr>
+      <p:grpSpPr>
+        <a:xfrm>
+          <a:off x="0" y="0"/>
+          <a:ext cx="0" cy="0"/>
+          <a:chOff x="0" y="0"/>
+          <a:chExt cx="0" cy="0"/>
+        </a:xfrm>
+      </p:grpSpPr>
+      <p:sp>
+        <p:nvSpPr>
+          <p:cNvPr id="2" name="Slide Image Placeholder 1"/>
+          <p:cNvSpPr>
+            <a:spLocks noGrp="1"/>
+          </p:cNvSpPr>
+          <p:nvPr>
+            <p:ph type="sldImg" idx="2"/>
+          </p:nvPr>
+        </p:nvSpPr>
+        <p:spPr/>
+      </p:sp>
+      <p:sp>
+        <p:nvSpPr>
+          <p:cNvPr id="3" name="Notes Placeholder 2"/>
+          <p:cNvSpPr>
+            <a:spLocks noGrp="1"/>
+          </p:cNvSpPr>
+          <p:nvPr>
+            <p:ph type="body" idx="3" sz="quarter"/>
+          </p:nvPr>
+        </p:nvSpPr>
+        <p:spPr/>
+        <p:txBody>
+          <a:bodyPr/>
+          <a:lstStyle/>
+          <a:p>
+            <a:r>
+              <a:t>SLIDE 13 — Model comparison table (about 2 minutes)</a:t>
+            </a:r>
+          </a:p>
+          <a:p/>
+          <a:p>
+            <a:r>
+              <a:t>Opening: This is our midterm scoreboard for predicting total medals in Rio 2016 for held-out countries.</a:t>
+            </a:r>
+          </a:p>
+          <a:p/>
+          <a:p>
+            <a:r>
+              <a:t>Say: Read the winner first. Ridge with all economic factors leads with R-squared about 0.673 and MAE about 3.708. That is our best regression model at midterm on this split. It means economic features together explain a substantial share of medal differences among countries, not just USA versus small nations.</a:t>
+            </a:r>
+          </a:p>
+          <a:p/>
+          <a:p>
+            <a:r>
+              <a:t>Say: Random forest is our strongest nonlinear model on this chart, around 0.481 R-squared and 4.367 MAE. It captures some nonlinear patterns but still trails full Ridge here. XGBoost and the single decision tree are farther back on R-squared in this deck; the shallow tree in particular can overfit the training countries and fail on the test set, which is why we cap depth and prefer Ridge and ensembles for now.</a:t>
+            </a:r>
+          </a:p>
+          <a:p/>
+          <a:p>
+            <a:r>
+              <a:t>Say: The grouped Ridge without GDP and population is intentionally harder: R-squared about 0.171, MAE about 5.873. That experiment shows grouping alone does not replace classic size and wealth indicators. It is still useful for stakeholders who want to talk about tiers of nations without naming GDP every time, but prediction suffers.</a:t>
+            </a:r>
+          </a:p>
+          <a:p/>
+          <a:p>
+            <a:r>
+              <a:t>Close: For medal totals we care about MAE and R-squared, not accuracy. Many countries have zero medals; accuracy would hide that.</a:t>
+            </a:r>
+          </a:p>
+          <a:p/>
+          <a:p>
+            <a:r>
+              <a:t>Transition: Slide 14 shows what good predictions look like visually for one of our groups.</a:t>
+            </a:r>
+          </a:p>
+        </p:txBody>
+      </p:sp>
+      <p:sp>
+        <p:nvSpPr>
+          <p:cNvPr id="4" name="Slide Number Placeholder 3"/>
+          <p:cNvSpPr>
+            <a:spLocks noGrp="1"/>
+          </p:cNvSpPr>
+          <p:nvPr>
+            <p:ph type="sldNum" idx="5" sz="quarter"/>
+          </p:nvPr>
+        </p:nvSpPr>
+        <p:spPr/>
+      </p:sp>
+    </p:spTree>
+  </p:cSld>
+  <p:clrMapOvr>
+    <a:masterClrMapping/>
+  </p:clrMapOvr>
+</p:notes>
+</file>
+
+<file path=ppt/notesSlides/notesSlide4.xml><?xml version="1.0" encoding="utf-8"?>
+<p:notes xmlns:a="http://schemas.openxmlformats.org/drawingml/2006/main" xmlns:p="http://schemas.openxmlformats.org/presentationml/2006/main" xmlns:r="http://schemas.openxmlformats.org/officeDocument/2006/relationships">
+  <p:cSld>
+    <p:spTree>
+      <p:nvGrpSpPr>
+        <p:cNvPr id="1" name=""/>
+        <p:cNvGrpSpPr/>
+        <p:nvPr/>
+      </p:nvGrpSpPr>
+      <p:grpSpPr>
+        <a:xfrm>
+          <a:off x="0" y="0"/>
+          <a:ext cx="0" cy="0"/>
+          <a:chOff x="0" y="0"/>
+          <a:chExt cx="0" cy="0"/>
+        </a:xfrm>
+      </p:grpSpPr>
+      <p:sp>
+        <p:nvSpPr>
+          <p:cNvPr id="2" name="Slide Image Placeholder 1"/>
+          <p:cNvSpPr>
+            <a:spLocks noGrp="1"/>
+          </p:cNvSpPr>
+          <p:nvPr>
+            <p:ph type="sldImg" idx="2"/>
+          </p:nvPr>
+        </p:nvSpPr>
+        <p:spPr/>
+      </p:sp>
+      <p:sp>
+        <p:nvSpPr>
+          <p:cNvPr id="3" name="Notes Placeholder 2"/>
+          <p:cNvSpPr>
+            <a:spLocks noGrp="1"/>
+          </p:cNvSpPr>
+          <p:nvPr>
+            <p:ph type="body" idx="3" sz="quarter"/>
+          </p:nvPr>
+        </p:nvSpPr>
+        <p:spPr/>
+        <p:txBody>
+          <a:bodyPr/>
+          <a:lstStyle/>
+          <a:p>
+            <a:r>
+              <a:t>SLIDE 14 — Actual versus predicted (about 1.5 minutes)</a:t>
+            </a:r>
+          </a:p>
+          <a:p/>
+          <a:p>
+            <a:r>
+              <a:t>Opening: Metrics are necessary; this plot makes the model behavior concrete.</a:t>
+            </a:r>
+          </a:p>
+          <a:p/>
+          <a:p>
+            <a:r>
+              <a:t>Say: Each point is a country in the test set. Horizontal axis is actual 2016 total medals; vertical axis is what the model predicted. Points near the diagonal line are good predictions. The upward trend means when a country actually wins more medals, our model tends to predict more, which is what we want from a regression model.</a:t>
+            </a:r>
+          </a:p>
+          <a:p/>
+          <a:p>
+            <a:r>
+              <a:t>Say: The slide calls out group 16 as an example slice of the data. Use that to explain we are not only modeling global giants; we also look inside similar country groups to see over- and under-performance relative to expectations.</a:t>
+            </a:r>
+          </a:p>
+          <a:p/>
+          <a:p>
+            <a:r>
+              <a:t>Say the honest limitation on the slide: the model struggles at the extremes. Very high medal totals like top Olympic powers are often under-predicted because a few nations dominate historically. Countries with zero or very few medals are also hard; economic data alone cannot capture sport-specific talent pipelines, hosting effects, or sports federation focus.</a:t>
+            </a:r>
+          </a:p>
+          <a:p/>
+          <a:p>
+            <a:r>
+              <a:t>If asked: this is correlation and prediction from one Games year with one train-test split; we are not claiming causality.</a:t>
+            </a:r>
+          </a:p>
+          <a:p/>
+          <a:p>
+            <a:r>
+              <a:t>Transition: Slide 15 summarizes takeaways for the class and stakeholders.</a:t>
+            </a:r>
+          </a:p>
+        </p:txBody>
+      </p:sp>
+      <p:sp>
+        <p:nvSpPr>
+          <p:cNvPr id="4" name="Slide Number Placeholder 3"/>
+          <p:cNvSpPr>
+            <a:spLocks noGrp="1"/>
+          </p:cNvSpPr>
+          <p:nvPr>
+            <p:ph type="sldNum" idx="5" sz="quarter"/>
+          </p:nvPr>
+        </p:nvSpPr>
+        <p:spPr/>
+      </p:sp>
+    </p:spTree>
+  </p:cSld>
+  <p:clrMapOvr>
+    <a:masterClrMapping/>
+  </p:clrMapOvr>
+</p:notes>
+</file>
+
+<file path=ppt/notesSlides/notesSlide5.xml><?xml version="1.0" encoding="utf-8"?>
+<p:notes xmlns:a="http://schemas.openxmlformats.org/drawingml/2006/main" xmlns:p="http://schemas.openxmlformats.org/presentationml/2006/main" xmlns:r="http://schemas.openxmlformats.org/officeDocument/2006/relationships">
+  <p:cSld>
+    <p:spTree>
+      <p:nvGrpSpPr>
+        <p:cNvPr id="1" name=""/>
+        <p:cNvGrpSpPr/>
+        <p:nvPr/>
+      </p:nvGrpSpPr>
+      <p:grpSpPr>
+        <a:xfrm>
+          <a:off x="0" y="0"/>
+          <a:ext cx="0" cy="0"/>
+          <a:chOff x="0" y="0"/>
+          <a:chExt cx="0" cy="0"/>
+        </a:xfrm>
+      </p:grpSpPr>
+      <p:sp>
+        <p:nvSpPr>
+          <p:cNvPr id="2" name="Slide Image Placeholder 1"/>
+          <p:cNvSpPr>
+            <a:spLocks noGrp="1"/>
+          </p:cNvSpPr>
+          <p:nvPr>
+            <p:ph type="sldImg" idx="2"/>
+          </p:nvPr>
+        </p:nvSpPr>
+        <p:spPr/>
+      </p:sp>
+      <p:sp>
+        <p:nvSpPr>
+          <p:cNvPr id="3" name="Notes Placeholder 2"/>
+          <p:cNvSpPr>
+            <a:spLocks noGrp="1"/>
+          </p:cNvSpPr>
+          <p:nvPr>
+            <p:ph type="body" idx="3" sz="quarter"/>
+          </p:nvPr>
+        </p:nvSpPr>
+        <p:spPr/>
+        <p:txBody>
+          <a:bodyPr/>
+          <a:lstStyle/>
+          <a:p>
+            <a:r>
+              <a:t>SLIDE 15 — Key findings (about 1.5 minutes)</a:t>
+            </a:r>
+          </a:p>
+          <a:p/>
+          <a:p>
+            <a:r>
+              <a:t>Opening: Three sentences a minister or NOC planner could remember.</a:t>
+            </a:r>
+          </a:p>
+          <a:p/>
+          <a:p>
+            <a:r>
+              <a:t>Say: First finding on the slide: the all-factor Ridge model is our strongest held-out performer, R-squared about 0.673, MAE about 3.708, versus about 6.781 MAE for the mean-only baseline. Economic indicators, taken together, add real predictive value for total medals among countries in our sample.</a:t>
+            </a:r>
+          </a:p>
+          <a:p/>
+          <a:p>
+            <a:r>
+              <a:t>Say: Second finding: when we remove GDP and population from the feature set and lean on country groups, performance drops sharply to R-squared about 0.171 and MAE about 5.873. Groups help interpretation and missing-data structure, but they do not fully substitute for classic resource variables from the literature.</a:t>
+            </a:r>
+          </a:p>
+          <a:p/>
+          <a:p>
+            <a:r>
+              <a:t>Say: Third point for discussion: within similar GDP and population bins, some countries still punch above or below expectations. That motivates our stakeholder metrics like medals per athlete and the efficiency work in the EDA notebook, not only raw totals.</a:t>
+            </a:r>
+          </a:p>
+          <a:p/>
+          <a:p>
+            <a:r>
+              <a:t>Transition: Slide 16 is where we admit what can go wrong and what we will do before the final.</a:t>
+            </a:r>
+          </a:p>
+        </p:txBody>
+      </p:sp>
+      <p:sp>
+        <p:nvSpPr>
+          <p:cNvPr id="4" name="Slide Number Placeholder 3"/>
+          <p:cNvSpPr>
+            <a:spLocks noGrp="1"/>
+          </p:cNvSpPr>
+          <p:nvPr>
+            <p:ph type="sldNum" idx="5" sz="quarter"/>
+          </p:nvPr>
+        </p:nvSpPr>
+        <p:spPr/>
+      </p:sp>
+    </p:spTree>
+  </p:cSld>
+  <p:clrMapOvr>
+    <a:masterClrMapping/>
+  </p:clrMapOvr>
+</p:notes>
+</file>
+
+<file path=ppt/notesSlides/notesSlide6.xml><?xml version="1.0" encoding="utf-8"?>
+<p:notes xmlns:a="http://schemas.openxmlformats.org/drawingml/2006/main" xmlns:p="http://schemas.openxmlformats.org/presentationml/2006/main" xmlns:r="http://schemas.openxmlformats.org/officeDocument/2006/relationships">
+  <p:cSld>
+    <p:spTree>
+      <p:nvGrpSpPr>
+        <p:cNvPr id="1" name=""/>
+        <p:cNvGrpSpPr/>
+        <p:nvPr/>
+      </p:nvGrpSpPr>
+      <p:grpSpPr>
+        <a:xfrm>
+          <a:off x="0" y="0"/>
+          <a:ext cx="0" cy="0"/>
+          <a:chOff x="0" y="0"/>
+          <a:chExt cx="0" cy="0"/>
+        </a:xfrm>
+      </p:grpSpPr>
+      <p:sp>
+        <p:nvSpPr>
+          <p:cNvPr id="2" name="Slide Image Placeholder 1"/>
+          <p:cNvSpPr>
+            <a:spLocks noGrp="1"/>
+          </p:cNvSpPr>
+          <p:nvPr>
+            <p:ph type="sldImg" idx="2"/>
+          </p:nvPr>
+        </p:nvSpPr>
+        <p:spPr/>
+      </p:sp>
+      <p:sp>
+        <p:nvSpPr>
+          <p:cNvPr id="3" name="Notes Placeholder 2"/>
+          <p:cNvSpPr>
+            <a:spLocks noGrp="1"/>
+          </p:cNvSpPr>
+          <p:nvPr>
+            <p:ph type="body" idx="3" sz="quarter"/>
+          </p:nvPr>
+        </p:nvSpPr>
+        <p:spPr/>
+        <p:txBody>
+          <a:bodyPr/>
+          <a:lstStyle/>
+          <a:p>
+            <a:r>
+              <a:t>SLIDE 16 — Limitations and next steps (about 2 minutes)</a:t>
+            </a:r>
+          </a:p>
+          <a:p/>
+          <a:p>
+            <a:r>
+              <a:t>Opening: Strong results on one split still have caveats; we want the class to trust us because we name them.</a:t>
+            </a:r>
+          </a:p>
+          <a:p/>
+          <a:p>
+            <a:r>
+              <a:t>Challenges — hit each bullet briefly:</a:t>
+            </a:r>
+          </a:p>
+          <a:p>
+            <a:r>
+              <a:t>• Missing WDI values: many lower-income countries have sparse indicators, so we require coverage thresholds and imputation. That can under-represent the nations Olympic Solidarity cares about most.</a:t>
+            </a:r>
+          </a:p>
+          <a:p>
+            <a:r>
+              <a:t>• Skewed medal counts: a handful of countries win most medals; means and errors are driven by that tail.</a:t>
+            </a:r>
+          </a:p>
+          <a:p>
+            <a:r>
+              <a:t>• Dominance of GDP and population: collinearity makes it hard to say which secondary indicator matters in linear models; tree models help but are less transparent.</a:t>
+            </a:r>
+          </a:p>
+          <a:p>
+            <a:r>
+              <a:t>• Association not causation: better health or education correlates with medals; we are not claiming a policy change guarantees podiums.</a:t>
+            </a:r>
+          </a:p>
+          <a:p/>
+          <a:p>
+            <a:r>
+              <a:t>Next steps — tie to the project plan:</a:t>
+            </a:r>
+          </a:p>
+          <a:p>
+            <a:r>
+              <a:t>• Train and test across multiple Olympic years so we are not only fitting Rio 2016.</a:t>
+            </a:r>
+          </a:p>
+          <a:p>
+            <a:r>
+              <a:t>• Hyperparameter tuning and consistent cross-validation for random forest, XGBoost, and LightGBM.</a:t>
+            </a:r>
+          </a:p>
+          <a:p>
+            <a:r>
+              <a:t>• Push medals-per-athlete and participation-adjusted metrics for the final report.</a:t>
+            </a:r>
+          </a:p>
+          <a:p>
+            <a:r>
+              <a:t>• Break errors out by income and population group to see systematic bias.</a:t>
+            </a:r>
+          </a:p>
+          <a:p>
+            <a:r>
+              <a:t>• Improve grouped models so we can interpret factors within tiers, not only at the global level.</a:t>
+            </a:r>
+          </a:p>
+          <a:p/>
+          <a:p>
+            <a:r>
+              <a:t>Transition: Slide 17 closes and opens Q&amp;A.</a:t>
+            </a:r>
+          </a:p>
+        </p:txBody>
+      </p:sp>
+      <p:sp>
+        <p:nvSpPr>
+          <p:cNvPr id="4" name="Slide Number Placeholder 3"/>
+          <p:cNvSpPr>
+            <a:spLocks noGrp="1"/>
+          </p:cNvSpPr>
+          <p:nvPr>
+            <p:ph type="sldNum" idx="5" sz="quarter"/>
+          </p:nvPr>
+        </p:nvSpPr>
+        <p:spPr/>
+      </p:sp>
+    </p:spTree>
+  </p:cSld>
+  <p:clrMapOvr>
+    <a:masterClrMapping/>
+  </p:clrMapOvr>
+</p:notes>
+</file>
+
+<file path=ppt/notesSlides/notesSlide7.xml><?xml version="1.0" encoding="utf-8"?>
+<p:notes xmlns:a="http://schemas.openxmlformats.org/drawingml/2006/main" xmlns:p="http://schemas.openxmlformats.org/presentationml/2006/main" xmlns:r="http://schemas.openxmlformats.org/officeDocument/2006/relationships">
+  <p:cSld>
+    <p:spTree>
+      <p:nvGrpSpPr>
+        <p:cNvPr id="1" name=""/>
+        <p:cNvGrpSpPr/>
+        <p:nvPr/>
+      </p:nvGrpSpPr>
+      <p:grpSpPr>
+        <a:xfrm>
+          <a:off x="0" y="0"/>
+          <a:ext cx="0" cy="0"/>
+          <a:chOff x="0" y="0"/>
+          <a:chExt cx="0" cy="0"/>
+        </a:xfrm>
+      </p:grpSpPr>
+      <p:sp>
+        <p:nvSpPr>
+          <p:cNvPr id="2" name="Slide Image Placeholder 1"/>
+          <p:cNvSpPr>
+            <a:spLocks noGrp="1"/>
+          </p:cNvSpPr>
+          <p:nvPr>
+            <p:ph type="sldImg" idx="2"/>
+          </p:nvPr>
+        </p:nvSpPr>
+        <p:spPr/>
+      </p:sp>
+      <p:sp>
+        <p:nvSpPr>
+          <p:cNvPr id="3" name="Notes Placeholder 2"/>
+          <p:cNvSpPr>
+            <a:spLocks noGrp="1"/>
+          </p:cNvSpPr>
+          <p:nvPr>
+            <p:ph type="body" idx="3" sz="quarter"/>
+          </p:nvPr>
+        </p:nvSpPr>
+        <p:spPr/>
+        <p:txBody>
+          <a:bodyPr/>
+          <a:lstStyle/>
+          <a:p>
+            <a:r>
+              <a:t>SLIDE 17 — Conclusion and Q&amp;A (about 1 minute, then discussion)</a:t>
+            </a:r>
+          </a:p>
+          <a:p/>
+          <a:p>
+            <a:r>
+              <a:t>CLOSING (say this first):</a:t>
+            </a:r>
+          </a:p>
+          <a:p>
+            <a:r>
+              <a:t>National economic conditions help explain Olympic medal totals in our merged World Bank and Olympedia data. Our best midterm regression model is Ridge with the full well-covered economic feature set: MAE about 3.708 medals versus about 6.781 for predicting the training mean every time. GDP and population still matter, but differences within similar country groups motivate our efficiency metrics and the rest of the semester.</a:t>
+            </a:r>
+          </a:p>
+          <a:p/>
+          <a:p>
+            <a:r>
+              <a:t>Thank Ahmad, Ethan, the class, and the instructor. Open the floor for questions.</a:t>
+            </a:r>
+          </a:p>
+          <a:p/>
+          <a:p>
+            <a:r>
+              <a:t>---</a:t>
+            </a:r>
+          </a:p>
+          <a:p/>
+          <a:p>
+            <a:r>
+              <a:t>Q&amp;A — likely questions and how to answer:</a:t>
+            </a:r>
+          </a:p>
+          <a:p/>
+          <a:p>
+            <a:r>
+              <a:t>Q: Why focus on 2016?</a:t>
+            </a:r>
+          </a:p>
+          <a:p>
+            <a:r>
+              <a:t>A: Rio is a clean snapshot where we have strong overlap between Olympic outcomes and WDI indicators, a full medal table, and enough countries for a 75/25 train-test split (about 201 countries in the modeling table, 51 held out). We will add multi-year train/test before the final.</a:t>
+            </a:r>
+          </a:p>
+          <a:p/>
+          <a:p>
+            <a:r>
+              <a:t>Q: Where does the data come from and why trust it?</a:t>
+            </a:r>
+          </a:p>
+          <a:p>
+            <a:r>
+              <a:t>A: Medals from Olympedia-style Olympic history; economics from the World Bank World Development Indicators, scraped and merged on country code and year into olympic_economics.csv on GitHub. WDI is standard for cross-country research; we drop very low-coverage indicators and document missingness in the notebook.</a:t>
+            </a:r>
+          </a:p>
+          <a:p/>
+          <a:p>
+            <a:r>
+              <a:t>Q: What is the null baseline again?</a:t>
+            </a:r>
+          </a:p>
+          <a:p>
+            <a:r>
+              <a:t>A: For regression, predict every test country gets the training-set average medal count. R-squared near zero and MAE about 6.8 on our slide. Real models must beat that.</a:t>
+            </a:r>
+          </a:p>
+          <a:p/>
+          <a:p>
+            <a:r>
+              <a:t>Q: Why did Ridge beat random forest and XGBoost on your slide?</a:t>
+            </a:r>
+          </a:p>
+          <a:p>
+            <a:r>
+              <a:t>A: One Olympic year, correlated features, and a single random split favor stable linear models. Trees can overfit with only ~150 training countries. We are tuning ensembles and using more years for the final.</a:t>
+            </a:r>
+          </a:p>
+          <a:p/>
+          <a:p>
+            <a:r>
+              <a:t>Q: Why not use accuracy?</a:t>
+            </a:r>
+          </a:p>
+          <a:p>
+            <a:r>
+              <a:t>A: Medal totals are skewed; many countries have zero. Accuracy hides errors on high-medal nations. We use MAE and R-squared for counts and F1 for the any-medal classification task.</a:t>
+            </a:r>
+          </a:p>
+          <a:p/>
+          <a:p>
+            <a:r>
+              <a:t>Q: Did you predict whether a country wins any medal?</a:t>
+            </a:r>
+          </a:p>
+          <a:p>
+            <a:r>
+              <a:t>A: Yes in the notebook: logistic regression with balanced classes, about 0.90 accuracy and 0.87 F1 on the same split, much better than always predicting no medal.</a:t>
+            </a:r>
+          </a:p>
+          <a:p/>
+          <a:p>
+            <a:r>
+              <a:t>Q: How are country groups defined?</a:t>
+            </a:r>
+          </a:p>
+          <a:p>
+            <a:r>
+              <a:t>A: From 2016 GDP per capita and population bins (see notebook Sections 14–18). Groups help EDA and missing-data structure; they do not fully replace GDP and population in prediction.</a:t>
+            </a:r>
+          </a:p>
+          <a:p/>
+          <a:p>
+            <a:r>
+              <a:t>Q: Does this prove spending on sports causes medals?</a:t>
+            </a:r>
+          </a:p>
+          <a:p>
+            <a:r>
+              <a:t>A: No. These are associations and predictions. Policy claims need causal designs we are not claiming at midterm.</a:t>
+            </a:r>
+          </a:p>
+          <a:p/>
+          <a:p>
+            <a:r>
+              <a:t>Q: What about host-nation effects or past medal history?</a:t>
+            </a:r>
+          </a:p>
+          <a:p>
+            <a:r>
+              <a:t>A: Important in literature; not our main midterm models. Planned as features or validation checks before the final.</a:t>
+            </a:r>
+          </a:p>
+          <a:p/>
+          <a:p>
+            <a:r>
+              <a:t>Q: Missing data for poor countries?</a:t>
+            </a:r>
+          </a:p>
+          <a:p>
+            <a:r>
+              <a:t>A: Major limitation. We require 80% indicator coverage among modeling countries and use median imputation, which can under-represent low-income nations Olympic Solidarity cares about.</a:t>
+            </a:r>
+          </a:p>
+          <a:p/>
+          <a:p>
+            <a:r>
+              <a:t>Q: Who are the stakeholders?</a:t>
+            </a:r>
+          </a:p>
+          <a:p>
+            <a:r>
+              <a:t>A: NOCs, sports ministries, IOC Solidarity, media, and athletes in developing nations needing evidence for funding, per our proposal.</a:t>
+            </a:r>
+          </a:p>
+          <a:p/>
+          <a:p>
+            <a:r>
+              <a:t>Q: What is next before the final?</a:t>
+            </a:r>
+          </a:p>
+          <a:p>
+            <a:r>
+              <a:t>A: Multi-year validation, LightGBM and hyperparameter tuning, PCA/clustering, medals-per-GDP and over/under-performance rankings, error analysis by income group.</a:t>
+            </a:r>
+          </a:p>
+          <a:p/>
+          <a:p>
+            <a:r>
+              <a:t>Q: Where is the code?</a:t>
+            </a:r>
+          </a:p>
+          <a:p>
+            <a:r>
+              <a:t>A: GitHub ahmadmashhood01/IST.707-PROJECT — notebooks olympic_economics_split_models.ipynb and related team notebooks; MIDTERM_REPORT.md on the repo.</a:t>
+            </a:r>
+          </a:p>
+          <a:p/>
+          <a:p>
+            <a:r>
+              <a:t>If you do not know: say which notebook section or report section you will verify after class; do not invent numbers.</a:t>
+            </a:r>
+          </a:p>
+        </p:txBody>
+      </p:sp>
+      <p:sp>
+        <p:nvSpPr>
+          <p:cNvPr id="4" name="Slide Number Placeholder 3"/>
+          <p:cNvSpPr>
+            <a:spLocks noGrp="1"/>
+          </p:cNvSpPr>
+          <p:nvPr>
+            <p:ph type="sldNum" idx="5" sz="quarter"/>
+          </p:nvPr>
+        </p:nvSpPr>
+        <p:spPr/>
+      </p:sp>
+    </p:spTree>
+  </p:cSld>
+  <p:clrMapOvr>
+    <a:masterClrMapping/>
+  </p:clrMapOvr>
+</p:notes>
 </file>
 
 <file path=ppt/slideLayouts/slideLayout1.xml><?xml version="1.0" encoding="utf-8"?>
@@ -7443,4 +8692,324 @@
   </a:objectDefaults>
   <a:extraClrSchemeLst/>
 </a:theme>
+</file>
+
+<file path=ppt/theme/theme2.xml><?xml version="1.0" encoding="utf-8"?>
+<a:theme xmlns:a="http://schemas.openxmlformats.org/drawingml/2006/main" name="Office Theme">
+  <a:themeElements>
+    <a:clrScheme name="Office">
+      <a:dk1>
+        <a:sysClr val="windowText" lastClr="000000"/>
+      </a:dk1>
+      <a:lt1>
+        <a:sysClr val="window" lastClr="FFFFFF"/>
+      </a:lt1>
+      <a:dk2>
+        <a:srgbClr val="1F497D"/>
+      </a:dk2>
+      <a:lt2>
+        <a:srgbClr val="EEECE1"/>
+      </a:lt2>
+      <a:accent1>
+        <a:srgbClr val="4F81BD"/>
+      </a:accent1>
+      <a:accent2>
+        <a:srgbClr val="C0504D"/>
+      </a:accent2>
+      <a:accent3>
+        <a:srgbClr val="9BBB59"/>
+      </a:accent3>
+      <a:accent4>
+        <a:srgbClr val="8064A2"/>
+      </a:accent4>
+      <a:accent5>
+        <a:srgbClr val="4BACC6"/>
+      </a:accent5>
+      <a:accent6>
+        <a:srgbClr val="F79646"/>
+      </a:accent6>
+      <a:hlink>
+        <a:srgbClr val="0000FF"/>
+      </a:hlink>
+      <a:folHlink>
+        <a:srgbClr val="800080"/>
+      </a:folHlink>
+    </a:clrScheme>
+    <a:fontScheme name="Office">
+      <a:majorFont>
+        <a:latin typeface="Calibri"/>
+        <a:ea typeface=""/>
+        <a:cs typeface=""/>
+        <a:font script="Jpan" typeface="ＭＳ Ｐゴシック"/>
+        <a:font script="Hang" typeface="맑은 고딕"/>
+        <a:font script="Hans" typeface="宋体"/>
+        <a:font script="Hant" typeface="新細明體"/>
+        <a:font script="Arab" typeface="Times New Roman"/>
+        <a:font script="Hebr" typeface="Times New Roman"/>
+        <a:font script="Thai" typeface="Angsana New"/>
+        <a:font script="Ethi" typeface="Nyala"/>
+        <a:font script="Beng" typeface="Vrinda"/>
+        <a:font script="Gujr" typeface="Shruti"/>
+        <a:font script="Khmr" typeface="MoolBoran"/>
+        <a:font script="Knda" typeface="Tunga"/>
+        <a:font script="Guru" typeface="Raavi"/>
+        <a:font script="Cans" typeface="Euphemia"/>
+        <a:font script="Cher" typeface="Plantagenet Cherokee"/>
+        <a:font script="Yiii" typeface="Microsoft Yi Baiti"/>
+        <a:font script="Tibt" typeface="Microsoft Himalaya"/>
+        <a:font script="Thaa" typeface="MV Boli"/>
+        <a:font script="Deva" typeface="Mangal"/>
+        <a:font script="Telu" typeface="Gautami"/>
+        <a:font script="Taml" typeface="Latha"/>
+        <a:font script="Syrc" typeface="Estrangelo Edessa"/>
+        <a:font script="Orya" typeface="Kalinga"/>
+        <a:font script="Mlym" typeface="Kartika"/>
+        <a:font script="Laoo" typeface="DokChampa"/>
+        <a:font script="Sinh" typeface="Iskoola Pota"/>
+        <a:font script="Mong" typeface="Mongolian Baiti"/>
+        <a:font script="Viet" typeface="Times New Roman"/>
+        <a:font script="Uigh" typeface="Microsoft Uighur"/>
+        <a:font script="Geor" typeface="Sylfaen"/>
+      </a:majorFont>
+      <a:minorFont>
+        <a:latin typeface="Calibri"/>
+        <a:ea typeface=""/>
+        <a:cs typeface=""/>
+        <a:font script="Jpan" typeface="ＭＳ Ｐゴシック"/>
+        <a:font script="Hang" typeface="맑은 고딕"/>
+        <a:font script="Hans" typeface="宋体"/>
+        <a:font script="Hant" typeface="新細明體"/>
+        <a:font script="Arab" typeface="Arial"/>
+        <a:font script="Hebr" typeface="Arial"/>
+        <a:font script="Thai" typeface="Cordia New"/>
+        <a:font script="Ethi" typeface="Nyala"/>
+        <a:font script="Beng" typeface="Vrinda"/>
+        <a:font script="Gujr" typeface="Shruti"/>
+        <a:font script="Khmr" typeface="DaunPenh"/>
+        <a:font script="Knda" typeface="Tunga"/>
+        <a:font script="Guru" typeface="Raavi"/>
+        <a:font script="Cans" typeface="Euphemia"/>
+        <a:font script="Cher" typeface="Plantagenet Cherokee"/>
+        <a:font script="Yiii" typeface="Microsoft Yi Baiti"/>
+        <a:font script="Tibt" typeface="Microsoft Himalaya"/>
+        <a:font script="Thaa" typeface="MV Boli"/>
+        <a:font script="Deva" typeface="Mangal"/>
+        <a:font script="Telu" typeface="Gautami"/>
+        <a:font script="Taml" typeface="Latha"/>
+        <a:font script="Syrc" typeface="Estrangelo Edessa"/>
+        <a:font script="Orya" typeface="Kalinga"/>
+        <a:font script="Mlym" typeface="Kartika"/>
+        <a:font script="Laoo" typeface="DokChampa"/>
+        <a:font script="Sinh" typeface="Iskoola Pota"/>
+        <a:font script="Mong" typeface="Mongolian Baiti"/>
+        <a:font script="Viet" typeface="Arial"/>
+        <a:font script="Uigh" typeface="Microsoft Uighur"/>
+        <a:font script="Geor" typeface="Sylfaen"/>
+      </a:minorFont>
+    </a:fontScheme>
+    <a:fmtScheme name="Office">
+      <a:fillStyleLst>
+        <a:solidFill>
+          <a:schemeClr val="phClr"/>
+        </a:solidFill>
+        <a:gradFill rotWithShape="1">
+          <a:gsLst>
+            <a:gs pos="0">
+              <a:schemeClr val="phClr">
+                <a:tint val="50000"/>
+                <a:satMod val="300000"/>
+              </a:schemeClr>
+            </a:gs>
+            <a:gs pos="35000">
+              <a:schemeClr val="phClr">
+                <a:tint val="37000"/>
+                <a:satMod val="300000"/>
+              </a:schemeClr>
+            </a:gs>
+            <a:gs pos="100000">
+              <a:schemeClr val="phClr">
+                <a:tint val="15000"/>
+                <a:satMod val="350000"/>
+              </a:schemeClr>
+            </a:gs>
+          </a:gsLst>
+          <a:lin ang="16200000" scaled="1"/>
+        </a:gradFill>
+        <a:gradFill rotWithShape="1">
+          <a:gsLst>
+            <a:gs pos="0">
+              <a:schemeClr val="phClr">
+                <a:tint val="100000"/>
+                <a:shade val="100000"/>
+                <a:satMod val="130000"/>
+              </a:schemeClr>
+            </a:gs>
+            <a:gs pos="100000">
+              <a:schemeClr val="phClr">
+                <a:tint val="50000"/>
+                <a:shade val="100000"/>
+                <a:satMod val="350000"/>
+              </a:schemeClr>
+            </a:gs>
+          </a:gsLst>
+          <a:lin ang="16200000" scaled="0"/>
+        </a:gradFill>
+      </a:fillStyleLst>
+      <a:lnStyleLst>
+        <a:ln w="9525" cap="flat" cmpd="sng" algn="ctr">
+          <a:solidFill>
+            <a:schemeClr val="phClr">
+              <a:shade val="95000"/>
+              <a:satMod val="105000"/>
+            </a:schemeClr>
+          </a:solidFill>
+          <a:prstDash val="solid"/>
+        </a:ln>
+        <a:ln w="25400" cap="flat" cmpd="sng" algn="ctr">
+          <a:solidFill>
+            <a:schemeClr val="phClr"/>
+          </a:solidFill>
+          <a:prstDash val="solid"/>
+        </a:ln>
+        <a:ln w="38100" cap="flat" cmpd="sng" algn="ctr">
+          <a:solidFill>
+            <a:schemeClr val="phClr"/>
+          </a:solidFill>
+          <a:prstDash val="solid"/>
+        </a:ln>
+      </a:lnStyleLst>
+      <a:effectStyleLst>
+        <a:effectStyle>
+          <a:effectLst>
+            <a:outerShdw blurRad="40000" dist="20000" dir="5400000" rotWithShape="0">
+              <a:srgbClr val="000000">
+                <a:alpha val="38000"/>
+              </a:srgbClr>
+            </a:outerShdw>
+          </a:effectLst>
+        </a:effectStyle>
+        <a:effectStyle>
+          <a:effectLst>
+            <a:outerShdw blurRad="40000" dist="23000" dir="5400000" rotWithShape="0">
+              <a:srgbClr val="000000">
+                <a:alpha val="35000"/>
+              </a:srgbClr>
+            </a:outerShdw>
+          </a:effectLst>
+        </a:effectStyle>
+        <a:effectStyle>
+          <a:effectLst>
+            <a:outerShdw blurRad="40000" dist="23000" dir="5400000" rotWithShape="0">
+              <a:srgbClr val="000000">
+                <a:alpha val="35000"/>
+              </a:srgbClr>
+            </a:outerShdw>
+          </a:effectLst>
+          <a:scene3d>
+            <a:camera prst="orthographicFront">
+              <a:rot lat="0" lon="0" rev="0"/>
+            </a:camera>
+            <a:lightRig rig="threePt" dir="t">
+              <a:rot lat="0" lon="0" rev="1200000"/>
+            </a:lightRig>
+          </a:scene3d>
+          <a:sp3d>
+            <a:bevelT w="63500" h="25400"/>
+          </a:sp3d>
+        </a:effectStyle>
+      </a:effectStyleLst>
+      <a:bgFillStyleLst>
+        <a:solidFill>
+          <a:schemeClr val="phClr"/>
+        </a:solidFill>
+        <a:gradFill rotWithShape="1">
+          <a:gsLst>
+            <a:gs pos="0">
+              <a:schemeClr val="phClr">
+                <a:tint val="40000"/>
+                <a:satMod val="350000"/>
+              </a:schemeClr>
+            </a:gs>
+            <a:gs pos="40000">
+              <a:schemeClr val="phClr">
+                <a:tint val="45000"/>
+                <a:shade val="99000"/>
+                <a:satMod val="350000"/>
+              </a:schemeClr>
+            </a:gs>
+            <a:gs pos="100000">
+              <a:schemeClr val="phClr">
+                <a:shade val="20000"/>
+                <a:satMod val="255000"/>
+              </a:schemeClr>
+            </a:gs>
+          </a:gsLst>
+          <a:path path="circle">
+            <a:fillToRect l="50000" t="-80000" r="50000" b="180000"/>
+          </a:path>
+        </a:gradFill>
+        <a:gradFill rotWithShape="1">
+          <a:gsLst>
+            <a:gs pos="0">
+              <a:schemeClr val="phClr">
+                <a:tint val="80000"/>
+                <a:satMod val="300000"/>
+              </a:schemeClr>
+            </a:gs>
+            <a:gs pos="100000">
+              <a:schemeClr val="phClr">
+                <a:shade val="30000"/>
+                <a:satMod val="200000"/>
+              </a:schemeClr>
+            </a:gs>
+          </a:gsLst>
+          <a:path path="circle">
+            <a:fillToRect l="50000" t="50000" r="50000" b="50000"/>
+          </a:path>
+        </a:gradFill>
+      </a:bgFillStyleLst>
+    </a:fmtScheme>
+  </a:themeElements>
+  <a:objectDefaults>
+    <a:spDef>
+      <a:spPr/>
+      <a:bodyPr/>
+      <a:lstStyle/>
+      <a:style>
+        <a:lnRef idx="1">
+          <a:schemeClr val="accent1"/>
+        </a:lnRef>
+        <a:fillRef idx="3">
+          <a:schemeClr val="accent1"/>
+        </a:fillRef>
+        <a:effectRef idx="2">
+          <a:schemeClr val="accent1"/>
+        </a:effectRef>
+        <a:fontRef idx="minor">
+          <a:schemeClr val="lt1"/>
+        </a:fontRef>
+      </a:style>
+    </a:spDef>
+    <a:lnDef>
+      <a:spPr/>
+      <a:bodyPr/>
+      <a:lstStyle/>
+      <a:style>
+        <a:lnRef idx="2">
+          <a:schemeClr val="accent1"/>
+        </a:lnRef>
+        <a:fillRef idx="0">
+          <a:schemeClr val="accent1"/>
+        </a:fillRef>
+        <a:effectRef idx="1">
+          <a:schemeClr val="accent1"/>
+        </a:effectRef>
+        <a:fontRef idx="minor">
+          <a:schemeClr val="tx1"/>
+        </a:fontRef>
+      </a:style>
+    </a:lnDef>
+  </a:objectDefaults>
+  <a:extraClrSchemeLst/>
+</a:theme>
 </file>
</xml_diff>

<commit_message>
Simplify midterm presentation speaker notes for slides 11 through 17.
</commit_message>
<xml_diff>
--- a/Olympic_Economics_Midterm Presentation.pptx
+++ b/Olympic_Economics_Midterm Presentation.pptx
@@ -534,37 +534,31 @@
           <a:lstStyle/>
           <a:p>
             <a:r>
-              <a:t>SLIDE 11 — Null baseline (about 1.5 minutes)</a:t>
+              <a:t>We start model evaluation with a null baseline so we know our models beat a naive guess.</a:t>
             </a:r>
           </a:p>
           <a:p/>
           <a:p>
             <a:r>
-              <a:t>Opening: This section is where we show whether our models are actually learning anything, or just repeating an obvious guess.</a:t>
+              <a:t>The null model predicts the same medal total for every country in the test set: the average medals from the training countries. It ignores population, GDP, team size, health spending, and all other features.</a:t>
             </a:r>
           </a:p>
           <a:p/>
           <a:p>
             <a:r>
-              <a:t>Say: Our null baseline for regression is deliberately dumb but fair. For every country in the 2016 test set, we predict the same number: the average total medals from the training countries. We ignore population, GDP, health spending, team size, and every other feature. That is the floor any real model has to beat.</a:t>
+              <a:t>We use the same 2016 holdout for every model: about 25% of countries held out, 51 countries in the test set. MAE is average error in medals. R-squared shows how much better we are than predicting one flat number.</a:t>
             </a:r>
           </a:p>
           <a:p/>
           <a:p>
             <a:r>
-              <a:t>Say: We report MAE and R-squared on the same 25 percent holdout of countries, with the same random split every time, so comparisons are apples to apples. MAE is in medals: how far off we are on average. R-squared tells us whether we explain variation beyond a flat guess.</a:t>
+              <a:t>On the slide: null baseline MAE is 6.781 medals and R-squared is -0.004. That is almost no explanatory power. The grouped null baseline MAE is 8.538 with R-squared still about -0.004.</a:t>
             </a:r>
           </a:p>
           <a:p/>
           <a:p>
             <a:r>
-              <a:t>Walk the numbers on the slide: Null baseline MAE about 6.8 medals and R-squared essentially zero, about negative 0.004. That means predicting the mean is almost useless for spread across countries. The grouped null variant is similar in R-squared; MAE can differ slightly depending on which countries sit in the test fold.</a:t>
-            </a:r>
-          </a:p>
-          <a:p/>
-          <a:p>
-            <a:r>
-              <a:t>Transition: If economic indicators matter, our Ridge and tree models should beat this baseline clearly on MAE and R-squared.</a:t>
+              <a:t>Any useful model should beat 6.781 MAE and get R-squared clearly above zero.</a:t>
             </a:r>
           </a:p>
         </p:txBody>
@@ -634,37 +628,37 @@
           <a:lstStyle/>
           <a:p>
             <a:r>
-              <a:t>SLIDE 12 — Ridge beats the null (about 1.5 minutes)</a:t>
+              <a:t>This slide shows that adding economic predictors helps a lot compared to the null.</a:t>
             </a:r>
           </a:p>
           <a:p/>
           <a:p>
             <a:r>
-              <a:t>Opening: Here we answer the first stakeholder question: do economic predictors add value beyond a constant guess?</a:t>
+              <a:t>Null baseline MAE: 6.781 medals.</a:t>
             </a:r>
           </a:p>
           <a:p/>
           <a:p>
             <a:r>
-              <a:t>Say: The left comparison is MAE for the plain null versus Ridge with all well-covered economic factors, about 33 indicators with at least 80 percent coverage among our 2016 modeling countries. Error drops from about 6.781 to about 3.708 medals on average. That is roughly a 45 percent reduction in MAE, which is a large practical improvement for planning scenarios.</a:t>
+              <a:t>Ridge with all well-covered economic factors: MAE 3.708. That is a 45.3% drop in average error versus the null.</a:t>
             </a:r>
           </a:p>
           <a:p/>
           <a:p>
             <a:r>
-              <a:t>Say: We also trained Ridge with country groups and without direct GDP and population columns in the feature matrix. That grouped Ridge lands around 5.873 MAE. It still beats the simple null on this slide in some setups, but it is much worse than the all-factor Ridge. The story is that size and wealth still carry a lot of signal, even when we try to summarize countries with groups.</a:t>
+              <a:t>Ridge with country groups and without GDP and population in the feature set: MAE 5.873. It improves on some baselines but is much worse than all-factor Ridge.</a:t>
             </a:r>
           </a:p>
           <a:p/>
           <a:p>
             <a:r>
-              <a:t>Point at the grouped null baseline number if shown (about 8.538): remind the audience that baselines must match the same sample; we always compare models trained and tested on the same countries.</a:t>
+              <a:t>Grouped null baseline MAE on the slide: 8.538. Always compare models on the same countries and the same train-test split.</a:t>
             </a:r>
           </a:p>
           <a:p/>
           <a:p>
             <a:r>
-              <a:t>Transition: Slide 13 puts every regression model side by side on R-squared and MAE.</a:t>
+              <a:t>Takeaway: the full economic feature set matters; grouping alone does not replace GDP and population.</a:t>
             </a:r>
           </a:p>
         </p:txBody>
@@ -734,43 +728,55 @@
           <a:lstStyle/>
           <a:p>
             <a:r>
-              <a:t>SLIDE 13 — Model comparison table (about 2 minutes)</a:t>
+              <a:t>Side-by-side regression results for 2016 total medals on the held-out test countries.</a:t>
             </a:r>
           </a:p>
           <a:p/>
           <a:p>
             <a:r>
-              <a:t>Opening: This is our midterm scoreboard for predicting total medals in Rio 2016 for held-out countries.</a:t>
+              <a:t>Null mean: R-squared -0.004, MAE 6.781.</a:t>
             </a:r>
           </a:p>
           <a:p/>
           <a:p>
             <a:r>
-              <a:t>Say: Read the winner first. Ridge with all economic factors leads with R-squared about 0.673 and MAE about 3.708. That is our best regression model at midterm on this split. It means economic features together explain a substantial share of medal differences among countries, not just USA versus small nations.</a:t>
+              <a:t>Ridge, all economic factors: R-squared 0.673, MAE 3.708. This is our best model on this slide.</a:t>
             </a:r>
           </a:p>
           <a:p/>
           <a:p>
             <a:r>
-              <a:t>Say: Random forest is our strongest nonlinear model on this chart, around 0.481 R-squared and 4.367 MAE. It captures some nonlinear patterns but still trails full Ridge here. XGBoost and the single decision tree are farther back on R-squared in this deck; the shallow tree in particular can overfit the training countries and fail on the test set, which is why we cap depth and prefer Ridge and ensembles for now.</a:t>
+              <a:t>Random forest: R-squared 0.481, MAE 4.367.</a:t>
             </a:r>
           </a:p>
           <a:p/>
           <a:p>
             <a:r>
-              <a:t>Say: The grouped Ridge without GDP and population is intentionally harder: R-squared about 0.171, MAE about 5.873. That experiment shows grouping alone does not replace classic size and wealth indicators. It is still useful for stakeholders who want to talk about tiers of nations without naming GDP every time, but prediction suffers.</a:t>
+              <a:t>Decision tree: R-squared 0.319, MAE 4.181.</a:t>
             </a:r>
           </a:p>
           <a:p/>
           <a:p>
             <a:r>
-              <a:t>Close: For medal totals we care about MAE and R-squared, not accuracy. Many countries have zero medals; accuracy would hide that.</a:t>
+              <a:t>XGBoost: R-squared 0.300, MAE 4.560.</a:t>
             </a:r>
           </a:p>
           <a:p/>
           <a:p>
             <a:r>
-              <a:t>Transition: Slide 14 shows what good predictions look like visually for one of our groups.</a:t>
+              <a:t>Ridge, grouped without GDP and population: R-squared 0.171, MAE 5.873.</a:t>
+            </a:r>
+          </a:p>
+          <a:p/>
+          <a:p>
+            <a:r>
+              <a:t>Ridge with all factors wins on both R-squared and MAE. GDP and population carry a lot of signal; the grouped model without them is weaker.</a:t>
+            </a:r>
+          </a:p>
+          <a:p/>
+          <a:p>
+            <a:r>
+              <a:t>We use MAE and R-squared for medal counts because many countries have zero medals and accuracy would be misleading.</a:t>
             </a:r>
           </a:p>
         </p:txBody>
@@ -840,43 +846,25 @@
           <a:lstStyle/>
           <a:p>
             <a:r>
-              <a:t>SLIDE 14 — Actual versus predicted (about 1.5 minutes)</a:t>
+              <a:t>This chart plots predicted versus actual total medals for test countries.</a:t>
             </a:r>
           </a:p>
           <a:p/>
           <a:p>
             <a:r>
-              <a:t>Opening: Metrics are necessary; this plot makes the model behavior concrete.</a:t>
+              <a:t>When actual medals go up, predictions usually go up too, so the model picks up real differences between countries. The example on the slide is for group 16.</a:t>
             </a:r>
           </a:p>
           <a:p/>
           <a:p>
             <a:r>
-              <a:t>Say: Each point is a country in the test set. Horizontal axis is actual 2016 total medals; vertical axis is what the model predicted. Points near the diagonal line are good predictions. The upward trend means when a country actually wins more medals, our model tends to predict more, which is what we want from a regression model.</a:t>
+              <a:t>The model is weaker at the extremes. Very high medal countries are often under-predicted. Countries with zero or very few medals are also hard because economics alone does not capture sport focus, hosting, or talent pipelines.</a:t>
             </a:r>
           </a:p>
           <a:p/>
           <a:p>
             <a:r>
-              <a:t>Say: The slide calls out group 16 as an example slice of the data. Use that to explain we are not only modeling global giants; we also look inside similar country groups to see over- and under-performance relative to expectations.</a:t>
-            </a:r>
-          </a:p>
-          <a:p/>
-          <a:p>
-            <a:r>
-              <a:t>Say the honest limitation on the slide: the model struggles at the extremes. Very high medal totals like top Olympic powers are often under-predicted because a few nations dominate historically. Countries with zero or very few medals are also hard; economic data alone cannot capture sport-specific talent pipelines, hosting effects, or sports federation focus.</a:t>
-            </a:r>
-          </a:p>
-          <a:p/>
-          <a:p>
-            <a:r>
-              <a:t>If asked: this is correlation and prediction from one Games year with one train-test split; we are not claiming causality.</a:t>
-            </a:r>
-          </a:p>
-          <a:p/>
-          <a:p>
-            <a:r>
-              <a:t>Transition: Slide 15 summarizes takeaways for the class and stakeholders.</a:t>
+              <a:t>This is prediction and association for one Olympic year, not proof that a policy change causes medals.</a:t>
             </a:r>
           </a:p>
         </p:txBody>
@@ -946,37 +934,25 @@
           <a:lstStyle/>
           <a:p>
             <a:r>
-              <a:t>SLIDE 15 — Key findings (about 1.5 minutes)</a:t>
+              <a:t>Three main findings from midterm modeling.</a:t>
             </a:r>
           </a:p>
           <a:p/>
           <a:p>
             <a:r>
-              <a:t>Opening: Three sentences a minister or NOC planner could remember.</a:t>
+              <a:t>First: all-factor Ridge is strongest on held-out data with R-squared 0.673 and MAE 3.708, versus null MAE 6.781.</a:t>
             </a:r>
           </a:p>
           <a:p/>
           <a:p>
             <a:r>
-              <a:t>Say: First finding on the slide: the all-factor Ridge model is our strongest held-out performer, R-squared about 0.673, MAE about 3.708, versus about 6.781 MAE for the mean-only baseline. Economic indicators, taken together, add real predictive value for total medals among countries in our sample.</a:t>
+              <a:t>Second: grouped Ridge without GDP and population has R-squared 0.171 and MAE 5.873. Grouping does not replace size and wealth variables.</a:t>
             </a:r>
           </a:p>
           <a:p/>
           <a:p>
             <a:r>
-              <a:t>Say: Second finding: when we remove GDP and population from the feature set and lean on country groups, performance drops sharply to R-squared about 0.171 and MAE about 5.873. Groups help interpretation and missing-data structure, but they do not fully substitute for classic resource variables from the literature.</a:t>
-            </a:r>
-          </a:p>
-          <a:p/>
-          <a:p>
-            <a:r>
-              <a:t>Say: Third point for discussion: within similar GDP and population bins, some countries still punch above or below expectations. That motivates our stakeholder metrics like medals per athlete and the efficiency work in the EDA notebook, not only raw totals.</a:t>
-            </a:r>
-          </a:p>
-          <a:p/>
-          <a:p>
-            <a:r>
-              <a:t>Transition: Slide 16 is where we admit what can go wrong and what we will do before the final.</a:t>
+              <a:t>Third: within similar GDP and population bins, some countries still over- or under-perform. That supports our stakeholder work on medals per athlete and efficiency, not only raw totals.</a:t>
             </a:r>
           </a:p>
         </p:txBody>
@@ -1046,76 +1022,37 @@
           <a:lstStyle/>
           <a:p>
             <a:r>
-              <a:t>SLIDE 16 — Limitations and next steps (about 2 minutes)</a:t>
+              <a:t>Limitations we are honest about.</a:t>
             </a:r>
           </a:p>
           <a:p/>
           <a:p>
             <a:r>
-              <a:t>Opening: Strong results on one split still have caveats; we want the class to trust us because we name them.</a:t>
+              <a:t>Missing WDI data varies by country and year, so we lose usable rows and impute medians. That can hurt low-income countries the most.</a:t>
             </a:r>
           </a:p>
           <a:p/>
           <a:p>
             <a:r>
-              <a:t>Challenges — hit each bullet briefly:</a:t>
-            </a:r>
-          </a:p>
-          <a:p>
-            <a:r>
-              <a:t>• Missing WDI values: many lower-income countries have sparse indicators, so we require coverage thresholds and imputation. That can under-represent the nations Olympic Solidarity cares about most.</a:t>
-            </a:r>
-          </a:p>
-          <a:p>
-            <a:r>
-              <a:t>• Skewed medal counts: a handful of countries win most medals; means and errors are driven by that tail.</a:t>
-            </a:r>
-          </a:p>
-          <a:p>
-            <a:r>
-              <a:t>• Dominance of GDP and population: collinearity makes it hard to say which secondary indicator matters in linear models; tree models help but are less transparent.</a:t>
-            </a:r>
-          </a:p>
-          <a:p>
-            <a:r>
-              <a:t>• Association not causation: better health or education correlates with medals; we are not claiming a policy change guarantees podiums.</a:t>
+              <a:t>Medal totals are skewed: a few countries win most medals.</a:t>
             </a:r>
           </a:p>
           <a:p/>
           <a:p>
             <a:r>
-              <a:t>Next steps — tie to the project plan:</a:t>
-            </a:r>
-          </a:p>
-          <a:p>
-            <a:r>
-              <a:t>• Train and test across multiple Olympic years so we are not only fitting Rio 2016.</a:t>
-            </a:r>
-          </a:p>
-          <a:p>
-            <a:r>
-              <a:t>• Hyperparameter tuning and consistent cross-validation for random forest, XGBoost, and LightGBM.</a:t>
-            </a:r>
-          </a:p>
-          <a:p>
-            <a:r>
-              <a:t>• Push medals-per-athlete and participation-adjusted metrics for the final report.</a:t>
-            </a:r>
-          </a:p>
-          <a:p>
-            <a:r>
-              <a:t>• Break errors out by income and population group to see systematic bias.</a:t>
-            </a:r>
-          </a:p>
-          <a:p>
-            <a:r>
-              <a:t>• Improve grouped models so we can interpret factors within tiers, not only at the global level.</a:t>
+              <a:t>GDP and population dominate many models; other indicators are harder to separate.</a:t>
             </a:r>
           </a:p>
           <a:p/>
           <a:p>
             <a:r>
-              <a:t>Transition: Slide 17 closes and opens Q&amp;A.</a:t>
+              <a:t>Correlation is not causation. We are not claiming sports spending causes medals.</a:t>
+            </a:r>
+          </a:p>
+          <a:p/>
+          <a:p>
+            <a:r>
+              <a:t>Next steps: validate on multiple Olympic years; tune random forest, XGBoost, and LightGBM with proper cross-validation; report medals per athlete and per GDP; check errors by income and size groups; improve models within country groups.</a:t>
             </a:r>
           </a:p>
         </p:txBody>
@@ -1185,185 +1122,73 @@
           <a:lstStyle/>
           <a:p>
             <a:r>
-              <a:t>SLIDE 17 — Conclusion and Q&amp;A (about 1 minute, then discussion)</a:t>
+              <a:t>Economic indicators help predict national Olympic medal totals in our merged World Bank and Olympic data.</a:t>
             </a:r>
           </a:p>
           <a:p/>
           <a:p>
             <a:r>
-              <a:t>CLOSING (say this first):</a:t>
-            </a:r>
-          </a:p>
-          <a:p>
-            <a:r>
-              <a:t>National economic conditions help explain Olympic medal totals in our merged World Bank and Olympedia data. Our best midterm regression model is Ridge with the full well-covered economic feature set: MAE about 3.708 medals versus about 6.781 for predicting the training mean every time. GDP and population still matter, but differences within similar country groups motivate our efficiency metrics and the rest of the semester.</a:t>
+              <a:t>Best regression on this deck: Ridge with the full economic feature set, MAE 3.708 versus 6.781 for the mean-only baseline. R-squared 0.673 versus about -0.004 for the null.</a:t>
             </a:r>
           </a:p>
           <a:p/>
           <a:p>
             <a:r>
-              <a:t>Thank Ahmad, Ethan, the class, and the instructor. Open the floor for questions.</a:t>
+              <a:t>GDP and population still matter. Differences inside similar groups are what we will study more before the final.</a:t>
             </a:r>
           </a:p>
           <a:p/>
           <a:p>
             <a:r>
-              <a:t>---</a:t>
+              <a:t>Code and data: GitHub repo ahmadmashhood01/IST.707-PROJECT. Main notebook: olympic_economics_split_models.ipynb. Written report: MIDTERM_REPORT.md.</a:t>
             </a:r>
           </a:p>
           <a:p/>
           <a:p>
             <a:r>
-              <a:t>Q&amp;A — likely questions and how to answer:</a:t>
+              <a:t>If someone asks why 2016: one clean year with good WDI overlap and 201 countries in the modeling table, 51 in the test set. We will add more years for the final.</a:t>
             </a:r>
           </a:p>
           <a:p/>
           <a:p>
             <a:r>
-              <a:t>Q: Why focus on 2016?</a:t>
-            </a:r>
-          </a:p>
-          <a:p>
-            <a:r>
-              <a:t>A: Rio is a clean snapshot where we have strong overlap between Olympic outcomes and WDI indicators, a full medal table, and enough countries for a 75/25 train-test split (about 201 countries in the modeling table, 51 held out). We will add multi-year train/test before the final.</a:t>
+              <a:t>If someone asks about data: Olympedia-style medals plus World Bank WDI merged on country and year into olympic_economics.csv, 13,584 rows and 74 columns in the full merge.</a:t>
             </a:r>
           </a:p>
           <a:p/>
           <a:p>
             <a:r>
-              <a:t>Q: Where does the data come from and why trust it?</a:t>
-            </a:r>
-          </a:p>
-          <a:p>
-            <a:r>
-              <a:t>A: Medals from Olympedia-style Olympic history; economics from the World Bank World Development Indicators, scraped and merged on country code and year into olympic_economics.csv on GitHub. WDI is standard for cross-country research; we drop very low-coverage indicators and document missingness in the notebook.</a:t>
+              <a:t>If someone asks why Ridge beat trees here: one year, correlated features, about 150 training countries; trees can overfit. We are tuning ensembles next.</a:t>
             </a:r>
           </a:p>
           <a:p/>
           <a:p>
             <a:r>
-              <a:t>Q: What is the null baseline again?</a:t>
-            </a:r>
-          </a:p>
-          <a:p>
-            <a:r>
-              <a:t>A: For regression, predict every test country gets the training-set average medal count. R-squared near zero and MAE about 6.8 on our slide. Real models must beat that.</a:t>
+              <a:t>If someone asks about winning any medal at all: in the notebook, logistic regression gets about 0.902 accuracy and 0.872 F1 on the same split, versus 0.608 accuracy and 0.000 F1 for always predicting no medal.</a:t>
             </a:r>
           </a:p>
           <a:p/>
           <a:p>
             <a:r>
-              <a:t>Q: Why did Ridge beat random forest and XGBoost on your slide?</a:t>
-            </a:r>
-          </a:p>
-          <a:p>
-            <a:r>
-              <a:t>A: One Olympic year, correlated features, and a single random split favor stable linear models. Trees can overfit with only ~150 training countries. We are tuning ensembles and using more years for the final.</a:t>
+              <a:t>If someone asks how groups are built: bins on 2016 GDP per capita and population in the notebook, sections 14 through 18.</a:t>
             </a:r>
           </a:p>
           <a:p/>
           <a:p>
             <a:r>
-              <a:t>Q: Why not use accuracy?</a:t>
-            </a:r>
-          </a:p>
-          <a:p>
-            <a:r>
-              <a:t>A: Medal totals are skewed; many countries have zero. Accuracy hides errors on high-medal nations. We use MAE and R-squared for counts and F1 for the any-medal classification task.</a:t>
+              <a:t>If someone asks about stakeholders: NOCs, sports ministries, IOC Solidarity, media, and athletes in developing countries, from our proposal.</a:t>
             </a:r>
           </a:p>
           <a:p/>
           <a:p>
             <a:r>
-              <a:t>Q: Did you predict whether a country wins any medal?</a:t>
-            </a:r>
-          </a:p>
-          <a:p>
-            <a:r>
-              <a:t>A: Yes in the notebook: logistic regression with balanced classes, about 0.90 accuracy and 0.87 F1 on the same split, much better than always predicting no medal.</a:t>
+              <a:t>If someone asks what we do not know yet: say you will check the notebook section or report rather than guessing a number.</a:t>
             </a:r>
           </a:p>
           <a:p/>
           <a:p>
             <a:r>
-              <a:t>Q: How are country groups defined?</a:t>
-            </a:r>
-          </a:p>
-          <a:p>
-            <a:r>
-              <a:t>A: From 2016 GDP per capita and population bins (see notebook Sections 14–18). Groups help EDA and missing-data structure; they do not fully replace GDP and population in prediction.</a:t>
-            </a:r>
-          </a:p>
-          <a:p/>
-          <a:p>
-            <a:r>
-              <a:t>Q: Does this prove spending on sports causes medals?</a:t>
-            </a:r>
-          </a:p>
-          <a:p>
-            <a:r>
-              <a:t>A: No. These are associations and predictions. Policy claims need causal designs we are not claiming at midterm.</a:t>
-            </a:r>
-          </a:p>
-          <a:p/>
-          <a:p>
-            <a:r>
-              <a:t>Q: What about host-nation effects or past medal history?</a:t>
-            </a:r>
-          </a:p>
-          <a:p>
-            <a:r>
-              <a:t>A: Important in literature; not our main midterm models. Planned as features or validation checks before the final.</a:t>
-            </a:r>
-          </a:p>
-          <a:p/>
-          <a:p>
-            <a:r>
-              <a:t>Q: Missing data for poor countries?</a:t>
-            </a:r>
-          </a:p>
-          <a:p>
-            <a:r>
-              <a:t>A: Major limitation. We require 80% indicator coverage among modeling countries and use median imputation, which can under-represent low-income nations Olympic Solidarity cares about.</a:t>
-            </a:r>
-          </a:p>
-          <a:p/>
-          <a:p>
-            <a:r>
-              <a:t>Q: Who are the stakeholders?</a:t>
-            </a:r>
-          </a:p>
-          <a:p>
-            <a:r>
-              <a:t>A: NOCs, sports ministries, IOC Solidarity, media, and athletes in developing nations needing evidence for funding, per our proposal.</a:t>
-            </a:r>
-          </a:p>
-          <a:p/>
-          <a:p>
-            <a:r>
-              <a:t>Q: What is next before the final?</a:t>
-            </a:r>
-          </a:p>
-          <a:p>
-            <a:r>
-              <a:t>A: Multi-year validation, LightGBM and hyperparameter tuning, PCA/clustering, medals-per-GDP and over/under-performance rankings, error analysis by income group.</a:t>
-            </a:r>
-          </a:p>
-          <a:p/>
-          <a:p>
-            <a:r>
-              <a:t>Q: Where is the code?</a:t>
-            </a:r>
-          </a:p>
-          <a:p>
-            <a:r>
-              <a:t>A: GitHub ahmadmashhood01/IST.707-PROJECT — notebooks olympic_economics_split_models.ipynb and related team notebooks; MIDTERM_REPORT.md on the repo.</a:t>
-            </a:r>
-          </a:p>
-          <a:p/>
-          <a:p>
-            <a:r>
-              <a:t>If you do not know: say which notebook section or report section you will verify after class; do not invent numbers.</a:t>
+              <a:t>Thanks for listening. Questions welcome.</a:t>
             </a:r>
           </a:p>
         </p:txBody>

</xml_diff>

<commit_message>
Update midterm presentation speaker notes for slides 11 through 17.
</commit_message>
<xml_diff>
--- a/Olympic_Economics_Midterm Presentation.pptx
+++ b/Olympic_Economics_Midterm Presentation.pptx
@@ -534,31 +534,37 @@
           <a:lstStyle/>
           <a:p>
             <a:r>
-              <a:t>We start model evaluation with a null baseline so we know our models beat a naive guess.</a:t>
+              <a:t>Now we're moving into model evaluation, where we test how accurately our models can predict Olympic medals.</a:t>
             </a:r>
           </a:p>
           <a:p/>
           <a:p>
             <a:r>
-              <a:t>The null model predicts the same medal total for every country in the test set: the average medals from the training countries. It ignores population, GDP, team size, health spending, and all other features.</a:t>
+              <a:t>First, we created a null baseline. This is basically the simplest possible model. Instead of considering GDP, population, or any other economic factors, it predicts the same number of medals for every country, based on the average in our training data.</a:t>
             </a:r>
           </a:p>
           <a:p/>
           <a:p>
             <a:r>
-              <a:t>We use the same 2016 holdout for every model: about 25% of countries held out, 51 countries in the test set. MAE is average error in medals. R-squared shows how much better we are than predicting one flat number.</a:t>
+              <a:t>We use this as a starting point to see whether machine learning actually improves our predictions.</a:t>
             </a:r>
           </a:p>
           <a:p/>
           <a:p>
             <a:r>
-              <a:t>On the slide: null baseline MAE is 6.781 medals and R-squared is -0.004. That is almost no explanatory power. The grouped null baseline MAE is 8.538 with R-squared still about -0.004.</a:t>
+              <a:t>To measure performance, we use two metrics: MAE, which tells us how many medals our predictions are off by on average, and R-squared, which tells us how well the model explains differences in medal counts.</a:t>
             </a:r>
           </a:p>
           <a:p/>
           <a:p>
             <a:r>
-              <a:t>Any useful model should beat 6.781 MAE and get R-squared clearly above zero.</a:t>
+              <a:t>Our baseline had an MAE of 6.781 medals, while the grouped baseline had an MAE of 8.538.</a:t>
+            </a:r>
+          </a:p>
+          <a:p/>
+          <a:p>
+            <a:r>
+              <a:t>So our goal is to build models that can reduce these errors.</a:t>
             </a:r>
           </a:p>
         </p:txBody>
@@ -628,37 +634,37 @@
           <a:lstStyle/>
           <a:p>
             <a:r>
-              <a:t>This slide shows that adding economic predictors helps a lot compared to the null.</a:t>
+              <a:t>Here we can see what happens when we actually introduce economic factors into our models.</a:t>
             </a:r>
           </a:p>
           <a:p/>
           <a:p>
             <a:r>
-              <a:t>Null baseline MAE: 6.781 medals.</a:t>
+              <a:t>The null baseline had an average error of 6.781 medals.</a:t>
             </a:r>
           </a:p>
           <a:p/>
           <a:p>
             <a:r>
-              <a:t>Ridge with all well-covered economic factors: MAE 3.708. That is a 45.3% drop in average error versus the null.</a:t>
+              <a:t>But when we used Ridge regression with all economic factors, that error dropped to just 3.708 medals.</a:t>
             </a:r>
           </a:p>
           <a:p/>
           <a:p>
             <a:r>
-              <a:t>Ridge with country groups and without GDP and population in the feature set: MAE 5.873. It improves on some baselines but is much worse than all-factor Ridge.</a:t>
+              <a:t>That's a 45.3% reduction in prediction error, which is a pretty significant improvement.</a:t>
             </a:r>
           </a:p>
           <a:p/>
           <a:p>
             <a:r>
-              <a:t>Grouped null baseline MAE on the slide: 8.538. Always compare models on the same countries and the same train-test split.</a:t>
+              <a:t>We also tested countries in separate economic and population groups. Their baseline error was 8.538, which decreased to 5.873 with Ridge regression.</a:t>
             </a:r>
           </a:p>
           <a:p/>
           <a:p>
             <a:r>
-              <a:t>Takeaway: the full economic feature set matters; grouping alone does not replace GDP and population.</a:t>
+              <a:t>So the main takeaway here is that economic indicators clearly add predictive value compared to simply guessing the average medal count.</a:t>
             </a:r>
           </a:p>
         </p:txBody>
@@ -728,55 +734,55 @@
           <a:lstStyle/>
           <a:p>
             <a:r>
-              <a:t>Side-by-side regression results for 2016 total medals on the held-out test countries.</a:t>
+              <a:t>Next, we compared several machine learning models to see which performed best.</a:t>
             </a:r>
           </a:p>
           <a:p/>
           <a:p>
             <a:r>
-              <a:t>Null mean: R-squared -0.004, MAE 6.781.</a:t>
+              <a:t>We tested Ridge regression, Random Forest, Decision Tree, and XGBoost.</a:t>
             </a:r>
           </a:p>
           <a:p/>
           <a:p>
             <a:r>
-              <a:t>Ridge, all economic factors: R-squared 0.673, MAE 3.708. This is our best model on this slide.</a:t>
+              <a:t>Looking at the results, Ridge regression using all economic factors performed the best.</a:t>
             </a:r>
           </a:p>
           <a:p/>
           <a:p>
             <a:r>
-              <a:t>Random forest: R-squared 0.481, MAE 4.367.</a:t>
+              <a:t>It achieved an R-squared of 0.673, meaning it explained about 67% of the variation in medal counts in our test data.</a:t>
             </a:r>
           </a:p>
           <a:p/>
           <a:p>
             <a:r>
-              <a:t>Decision tree: R-squared 0.319, MAE 4.181.</a:t>
+              <a:t>It also had the lowest MAE at 3.708 medals.</a:t>
             </a:r>
           </a:p>
           <a:p/>
           <a:p>
             <a:r>
-              <a:t>XGBoost: R-squared 0.300, MAE 4.560.</a:t>
+              <a:t>Random Forest came next, with an R-squared of 0.481.</a:t>
             </a:r>
           </a:p>
           <a:p/>
           <a:p>
             <a:r>
-              <a:t>Ridge, grouped without GDP and population: R-squared 0.171, MAE 5.873.</a:t>
+              <a:t>Interestingly, even though Random Forest and XGBoost are more complex models, they didn't outperform Ridge regression.</a:t>
             </a:r>
           </a:p>
           <a:p/>
           <a:p>
             <a:r>
-              <a:t>Ridge with all factors wins on both R-squared and MAE. GDP and population carry a lot of signal; the grouped model without them is weaker.</a:t>
+              <a:t>Our grouped Ridge model also performed worse, suggesting that GDP and population contain important predictive information.</a:t>
             </a:r>
           </a:p>
           <a:p/>
           <a:p>
             <a:r>
-              <a:t>We use MAE and R-squared for medal counts because many countries have zero medals and accuracy would be misleading.</a:t>
+              <a:t>So in this case, the simpler Ridge regression model actually gave us the strongest results.</a:t>
             </a:r>
           </a:p>
         </p:txBody>
@@ -846,25 +852,49 @@
           <a:lstStyle/>
           <a:p>
             <a:r>
-              <a:t>This chart plots predicted versus actual total medals for test countries.</a:t>
+              <a:t>Now let's look at how our model performs when predicting whether a country wins a medal.</a:t>
             </a:r>
           </a:p>
           <a:p/>
           <a:p>
             <a:r>
-              <a:t>When actual medals go up, predictions usually go up too, so the model picks up real differences between countries. The example on the slide is for group 16.</a:t>
+              <a:t>The chart here is a confusion matrix from logistic regression.</a:t>
             </a:r>
           </a:p>
           <a:p/>
           <a:p>
             <a:r>
-              <a:t>The model is weaker at the extremes. Very high medal countries are often under-predicted. Countries with zero or very few medals are also hard because economics alone does not capture sport focus, hosting, or talent pipelines.</a:t>
+              <a:t>On the top left, we have 29 countries that correctly predicted to win no medals.</a:t>
             </a:r>
           </a:p>
           <a:p/>
           <a:p>
             <a:r>
-              <a:t>This is prediction and association for one Olympic year, not proof that a policy change causes medals.</a:t>
+              <a:t>On the bottom right, we have 17 countries correctly predicted to win at least one medal.</a:t>
+            </a:r>
+          </a:p>
+          <a:p/>
+          <a:p>
+            <a:r>
+              <a:t>There were also two countries incorrectly predicted to win medals, and three countries incorrectly predicted to win none.</a:t>
+            </a:r>
+          </a:p>
+          <a:p/>
+          <a:p>
+            <a:r>
+              <a:t>So overall, the model correctly classified 46 out of 51 countries.</a:t>
+            </a:r>
+          </a:p>
+          <a:p/>
+          <a:p>
+            <a:r>
+              <a:t>This suggests that economic factors can help us distinguish between countries that win medals and those that don't.</a:t>
+            </a:r>
+          </a:p>
+          <a:p/>
+          <a:p>
+            <a:r>
+              <a:t>However, predicting whether a country wins any medal is different from accurately predicting its total number of medals.</a:t>
             </a:r>
           </a:p>
         </p:txBody>
@@ -934,25 +964,43 @@
           <a:lstStyle/>
           <a:p>
             <a:r>
-              <a:t>Three main findings from midterm modeling.</a:t>
+              <a:t>So what did we actually learn from these experiments?</a:t>
             </a:r>
           </a:p>
           <a:p/>
           <a:p>
             <a:r>
-              <a:t>First: all-factor Ridge is strongest on held-out data with R-squared 0.673 and MAE 3.708, versus null MAE 6.781.</a:t>
+              <a:t>Our biggest finding is that economic conditions are useful for predicting Olympic success.</a:t>
             </a:r>
           </a:p>
           <a:p/>
           <a:p>
             <a:r>
-              <a:t>Second: grouped Ridge without GDP and population has R-squared 0.171 and MAE 5.873. Grouping does not replace size and wealth variables.</a:t>
+              <a:t>The Ridge regression model using all economic indicators achieved the best performance, with an R-squared of 0.673 and an average error of about 3.7 medals.</a:t>
             </a:r>
           </a:p>
           <a:p/>
           <a:p>
             <a:r>
-              <a:t>Third: within similar GDP and population bins, some countries still over- or under-perform. That supports our stakeholder work on medals per athlete and efficiency, not only raw totals.</a:t>
+              <a:t>If you look at the graph, the dotted line represents perfect predictions. The closer a point is to that line, the more accurate our prediction is.</a:t>
+            </a:r>
+          </a:p>
+          <a:p/>
+          <a:p>
+            <a:r>
+              <a:t>We can see that several predictions are close, but there are also some significant errors.</a:t>
+            </a:r>
+          </a:p>
+          <a:p/>
+          <a:p>
+            <a:r>
+              <a:t>Another important finding is that when we removed GDP and population from the grouped model, performance dropped substantially.</a:t>
+            </a:r>
+          </a:p>
+          <a:p/>
+          <a:p>
+            <a:r>
+              <a:t>This tells us that GDP and population are especially important predictors, and grouping countries doesn't fully replace that information.</a:t>
             </a:r>
           </a:p>
         </p:txBody>
@@ -1022,37 +1070,43 @@
           <a:lstStyle/>
           <a:p>
             <a:r>
-              <a:t>Limitations we are honest about.</a:t>
+              <a:t>Of course, our study also had some limitations.</a:t>
             </a:r>
           </a:p>
           <a:p/>
           <a:p>
             <a:r>
-              <a:t>Missing WDI data varies by country and year, so we lose usable rows and impute medians. That can hurt low-income countries the most.</a:t>
+              <a:t>One major challenge was missing data. Not every country reports the same economic indicators, especially across different years.</a:t>
             </a:r>
           </a:p>
           <a:p/>
           <a:p>
             <a:r>
-              <a:t>Medal totals are skewed: a few countries win most medals.</a:t>
+              <a:t>Another challenge is that Olympic medals are not evenly distributed. A small number of countries win a large percentage of the medals, making predictions more difficult.</a:t>
             </a:r>
           </a:p>
           <a:p/>
           <a:p>
             <a:r>
-              <a:t>GDP and population dominate many models; other indicators are harder to separate.</a:t>
+              <a:t>We also found that GDP and population are such strong predictors that they can overshadow other economic factors.</a:t>
             </a:r>
           </a:p>
           <a:p/>
           <a:p>
             <a:r>
-              <a:t>Correlation is not causation. We are not claiming sports spending causes medals.</a:t>
+              <a:t>For future work, we'd like to test our models across multiple Olympic years, improve our model tuning, and look more closely at medals per athlete rather than just total medals.</a:t>
             </a:r>
           </a:p>
           <a:p/>
           <a:p>
             <a:r>
-              <a:t>Next steps: validate on multiple Olympic years; tune random forest, XGBoost, and LightGBM with proper cross-validation; report medals per athlete and per GDP; check errors by income and size groups; improve models within country groups.</a:t>
+              <a:t>We also want to examine whether our models systematically perform better for certain income or population groups.</a:t>
+            </a:r>
+          </a:p>
+          <a:p/>
+          <a:p>
+            <a:r>
+              <a:t>And importantly, correlation doesn't mean causation. Just because wealthier countries tend to win more medals doesn't necessarily mean increasing GDP directly causes more medals.</a:t>
             </a:r>
           </a:p>
         </p:txBody>
@@ -1122,73 +1176,43 @@
           <a:lstStyle/>
           <a:p>
             <a:r>
-              <a:t>Economic indicators help predict national Olympic medal totals in our merged World Bank and Olympic data.</a:t>
+              <a:t>To conclude, our research shows that economic conditions can help explain and predict Olympic success.</a:t>
             </a:r>
           </a:p>
           <a:p/>
           <a:p>
             <a:r>
-              <a:t>Best regression on this deck: Ridge with the full economic feature set, MAE 3.708 versus 6.781 for the mean-only baseline. R-squared 0.673 versus about -0.004 for the null.</a:t>
+              <a:t>By combining Olympic medal data with economic indicators, we were able to significantly improve prediction accuracy compared to a simple baseline.</a:t>
             </a:r>
           </a:p>
           <a:p/>
           <a:p>
             <a:r>
-              <a:t>GDP and population still matter. Differences inside similar groups are what we will study more before the final.</a:t>
+              <a:t>Our best model, Ridge regression, reduced the average prediction error from 6.781 to 3.708 medals.</a:t>
             </a:r>
           </a:p>
           <a:p/>
           <a:p>
             <a:r>
-              <a:t>Code and data: GitHub repo ahmadmashhood01/IST.707-PROJECT. Main notebook: olympic_economics_split_models.ipynb. Written report: MIDTERM_REPORT.md.</a:t>
+              <a:t>We also confirmed that GDP and population are important predictors, but they don't tell the entire story.</a:t>
             </a:r>
           </a:p>
           <a:p/>
           <a:p>
             <a:r>
-              <a:t>If someone asks why 2016: one clean year with good WDI overlap and 201 countries in the modeling table, 51 in the test set. We will add more years for the final.</a:t>
+              <a:t>Countries with similar economic conditions can still perform very differently, which suggests that other factors, including sports infrastructure, training, and national investment priorities, may also matter.</a:t>
             </a:r>
           </a:p>
           <a:p/>
           <a:p>
             <a:r>
-              <a:t>If someone asks about data: Olympedia-style medals plus World Bank WDI merged on country and year into olympic_economics.csv, 13,584 rows and 74 columns in the full merge.</a:t>
+              <a:t>So the main takeaway is that economic resources help explain Olympic performance, but they don't determine success on their own.</a:t>
             </a:r>
           </a:p>
           <a:p/>
           <a:p>
             <a:r>
-              <a:t>If someone asks why Ridge beat trees here: one year, correlated features, about 150 training countries; trees can overfit. We are tuning ensembles next.</a:t>
-            </a:r>
-          </a:p>
-          <a:p/>
-          <a:p>
-            <a:r>
-              <a:t>If someone asks about winning any medal at all: in the notebook, logistic regression gets about 0.902 accuracy and 0.872 F1 on the same split, versus 0.608 accuracy and 0.000 F1 for always predicting no medal.</a:t>
-            </a:r>
-          </a:p>
-          <a:p/>
-          <a:p>
-            <a:r>
-              <a:t>If someone asks how groups are built: bins on 2016 GDP per capita and population in the notebook, sections 14 through 18.</a:t>
-            </a:r>
-          </a:p>
-          <a:p/>
-          <a:p>
-            <a:r>
-              <a:t>If someone asks about stakeholders: NOCs, sports ministries, IOC Solidarity, media, and athletes in developing countries, from our proposal.</a:t>
-            </a:r>
-          </a:p>
-          <a:p/>
-          <a:p>
-            <a:r>
-              <a:t>If someone asks what we do not know yet: say you will check the notebook section or report rather than guessing a number.</a:t>
-            </a:r>
-          </a:p>
-          <a:p/>
-          <a:p>
-            <a:r>
-              <a:t>Thanks for listening. Questions welcome.</a:t>
+              <a:t>Thank you, and we're happy to take any questions.</a:t>
             </a:r>
           </a:p>
         </p:txBody>

</xml_diff>